<commit_message>
Work in progress presented at Weekly 20250527
</commit_message>
<xml_diff>
--- a/ContributionsForDiscussions/onmi2025.ND.002-LinkCreationAndModificationViaConnectivityService.pptx
+++ b/ContributionsForDiscussions/onmi2025.ND.002-LinkCreationAndModificationViaConnectivityService.pptx
@@ -7,12 +7,17 @@
   <p:sldIdLst>
     <p:sldId id="256" r:id="rId2"/>
     <p:sldId id="259" r:id="rId3"/>
-    <p:sldId id="260" r:id="rId4"/>
-    <p:sldId id="261" r:id="rId5"/>
-    <p:sldId id="262" r:id="rId6"/>
-    <p:sldId id="263" r:id="rId7"/>
-    <p:sldId id="258" r:id="rId8"/>
-    <p:sldId id="257" r:id="rId9"/>
+    <p:sldId id="271" r:id="rId4"/>
+    <p:sldId id="272" r:id="rId5"/>
+    <p:sldId id="269" r:id="rId6"/>
+    <p:sldId id="260" r:id="rId7"/>
+    <p:sldId id="264" r:id="rId8"/>
+    <p:sldId id="262" r:id="rId9"/>
+    <p:sldId id="261" r:id="rId10"/>
+    <p:sldId id="263" r:id="rId11"/>
+    <p:sldId id="258" r:id="rId12"/>
+    <p:sldId id="257" r:id="rId13"/>
+    <p:sldId id="268" r:id="rId14"/>
   </p:sldIdLst>
   <p:sldSz cx="12192000" cy="6858000"/>
   <p:notesSz cx="6858000" cy="9144000"/>
@@ -111,7 +116,20 @@
       </a:defRPr>
     </a:lvl9pPr>
   </p:defaultTextStyle>
+  <p:extLst>
+    <p:ext uri="{EFAFB233-063F-42B5-8137-9DF3F51BA10A}">
+      <p15:sldGuideLst xmlns:p15="http://schemas.microsoft.com/office/powerpoint/2012/main"/>
+    </p:ext>
+  </p:extLst>
 </p:presentation>
+</file>
+
+<file path=ppt/revisionInfo.xml><?xml version="1.0" encoding="utf-8"?>
+<p1510:revInfo xmlns:a="http://schemas.openxmlformats.org/drawingml/2006/main" xmlns:r="http://schemas.openxmlformats.org/officeDocument/2006/relationships" xmlns:p1510="http://schemas.microsoft.com/office/powerpoint/2015/10/main">
+  <p1510:revLst>
+    <p1510:client id="{E2A569F2-6D30-4074-83D1-1C83FCD2F229}" v="67" dt="2025-05-27T14:34:20.076"/>
+  </p1510:revLst>
+</p1510:revInfo>
 </file>
 
 <file path=ppt/slideLayouts/slideLayout1.xml><?xml version="1.0" encoding="utf-8"?>
@@ -261,7 +279,7 @@
           <a:p>
             <a:fld id="{58390B2C-3E23-46E0-8CF1-426A8FC22060}" type="datetimeFigureOut">
               <a:rPr lang="en-GB" smtClean="0"/>
-              <a:t>22/04/2025</a:t>
+              <a:t>27/05/2025</a:t>
             </a:fld>
             <a:endParaRPr lang="en-GB"/>
           </a:p>
@@ -459,7 +477,7 @@
           <a:p>
             <a:fld id="{58390B2C-3E23-46E0-8CF1-426A8FC22060}" type="datetimeFigureOut">
               <a:rPr lang="en-GB" smtClean="0"/>
-              <a:t>22/04/2025</a:t>
+              <a:t>27/05/2025</a:t>
             </a:fld>
             <a:endParaRPr lang="en-GB"/>
           </a:p>
@@ -667,7 +685,7 @@
           <a:p>
             <a:fld id="{58390B2C-3E23-46E0-8CF1-426A8FC22060}" type="datetimeFigureOut">
               <a:rPr lang="en-GB" smtClean="0"/>
-              <a:t>22/04/2025</a:t>
+              <a:t>27/05/2025</a:t>
             </a:fld>
             <a:endParaRPr lang="en-GB"/>
           </a:p>
@@ -865,7 +883,7 @@
           <a:p>
             <a:fld id="{58390B2C-3E23-46E0-8CF1-426A8FC22060}" type="datetimeFigureOut">
               <a:rPr lang="en-GB" smtClean="0"/>
-              <a:t>22/04/2025</a:t>
+              <a:t>27/05/2025</a:t>
             </a:fld>
             <a:endParaRPr lang="en-GB"/>
           </a:p>
@@ -1140,7 +1158,7 @@
           <a:p>
             <a:fld id="{58390B2C-3E23-46E0-8CF1-426A8FC22060}" type="datetimeFigureOut">
               <a:rPr lang="en-GB" smtClean="0"/>
-              <a:t>22/04/2025</a:t>
+              <a:t>27/05/2025</a:t>
             </a:fld>
             <a:endParaRPr lang="en-GB"/>
           </a:p>
@@ -1405,7 +1423,7 @@
           <a:p>
             <a:fld id="{58390B2C-3E23-46E0-8CF1-426A8FC22060}" type="datetimeFigureOut">
               <a:rPr lang="en-GB" smtClean="0"/>
-              <a:t>22/04/2025</a:t>
+              <a:t>27/05/2025</a:t>
             </a:fld>
             <a:endParaRPr lang="en-GB"/>
           </a:p>
@@ -1817,7 +1835,7 @@
           <a:p>
             <a:fld id="{58390B2C-3E23-46E0-8CF1-426A8FC22060}" type="datetimeFigureOut">
               <a:rPr lang="en-GB" smtClean="0"/>
-              <a:t>22/04/2025</a:t>
+              <a:t>27/05/2025</a:t>
             </a:fld>
             <a:endParaRPr lang="en-GB"/>
           </a:p>
@@ -1958,7 +1976,7 @@
           <a:p>
             <a:fld id="{58390B2C-3E23-46E0-8CF1-426A8FC22060}" type="datetimeFigureOut">
               <a:rPr lang="en-GB" smtClean="0"/>
-              <a:t>22/04/2025</a:t>
+              <a:t>27/05/2025</a:t>
             </a:fld>
             <a:endParaRPr lang="en-GB"/>
           </a:p>
@@ -2071,7 +2089,7 @@
           <a:p>
             <a:fld id="{58390B2C-3E23-46E0-8CF1-426A8FC22060}" type="datetimeFigureOut">
               <a:rPr lang="en-GB" smtClean="0"/>
-              <a:t>22/04/2025</a:t>
+              <a:t>27/05/2025</a:t>
             </a:fld>
             <a:endParaRPr lang="en-GB"/>
           </a:p>
@@ -2382,7 +2400,7 @@
           <a:p>
             <a:fld id="{58390B2C-3E23-46E0-8CF1-426A8FC22060}" type="datetimeFigureOut">
               <a:rPr lang="en-GB" smtClean="0"/>
-              <a:t>22/04/2025</a:t>
+              <a:t>27/05/2025</a:t>
             </a:fld>
             <a:endParaRPr lang="en-GB"/>
           </a:p>
@@ -2670,7 +2688,7 @@
           <a:p>
             <a:fld id="{58390B2C-3E23-46E0-8CF1-426A8FC22060}" type="datetimeFigureOut">
               <a:rPr lang="en-GB" smtClean="0"/>
-              <a:t>22/04/2025</a:t>
+              <a:t>27/05/2025</a:t>
             </a:fld>
             <a:endParaRPr lang="en-GB"/>
           </a:p>
@@ -2911,7 +2929,7 @@
           <a:p>
             <a:fld id="{58390B2C-3E23-46E0-8CF1-426A8FC22060}" type="datetimeFigureOut">
               <a:rPr lang="en-GB" smtClean="0"/>
-              <a:t>22/04/2025</a:t>
+              <a:t>27/05/2025</a:t>
             </a:fld>
             <a:endParaRPr lang="en-GB"/>
           </a:p>
@@ -3392,6 +3410,115 @@
           </a:p>
         </p:txBody>
       </p:sp>
+      <p:sp>
+        <p:nvSpPr>
+          <p:cNvPr id="4" name="Rectangle 3">
+            <a:extLst>
+              <a:ext uri="{FF2B5EF4-FFF2-40B4-BE49-F238E27FC236}">
+                <a16:creationId xmlns:a16="http://schemas.microsoft.com/office/drawing/2014/main" id="{FDAF5B4D-83C8-91C2-25AF-88F42319B434}"/>
+              </a:ext>
+            </a:extLst>
+          </p:cNvPr>
+          <p:cNvSpPr/>
+          <p:nvPr/>
+        </p:nvSpPr>
+        <p:spPr>
+          <a:xfrm rot="19164713">
+            <a:off x="-636291" y="2478912"/>
+            <a:ext cx="6698051" cy="2062103"/>
+          </a:xfrm>
+          <a:prstGeom prst="rect">
+            <a:avLst/>
+          </a:prstGeom>
+          <a:noFill/>
+        </p:spPr>
+        <p:txBody>
+          <a:bodyPr wrap="none" lIns="91440" tIns="45720" rIns="91440" bIns="45720">
+            <a:spAutoFit/>
+          </a:bodyPr>
+          <a:lstStyle/>
+          <a:p>
+            <a:pPr algn="ctr"/>
+            <a:r>
+              <a:rPr lang="en-GB" sz="3200" b="1" dirty="0">
+                <a:ln w="22225">
+                  <a:solidFill>
+                    <a:schemeClr val="accent2"/>
+                  </a:solidFill>
+                  <a:prstDash val="solid"/>
+                </a:ln>
+                <a:solidFill>
+                  <a:schemeClr val="accent2">
+                    <a:lumMod val="40000"/>
+                    <a:lumOff val="60000"/>
+                  </a:schemeClr>
+                </a:solidFill>
+              </a:rPr>
+              <a:t>This is work in progress</a:t>
+            </a:r>
+          </a:p>
+          <a:p>
+            <a:pPr algn="ctr"/>
+            <a:r>
+              <a:rPr lang="en-GB" sz="3200" b="1" dirty="0">
+                <a:ln w="22225">
+                  <a:solidFill>
+                    <a:schemeClr val="accent2"/>
+                  </a:solidFill>
+                  <a:prstDash val="solid"/>
+                </a:ln>
+                <a:solidFill>
+                  <a:schemeClr val="accent2">
+                    <a:lumMod val="40000"/>
+                    <a:lumOff val="60000"/>
+                  </a:schemeClr>
+                </a:solidFill>
+              </a:rPr>
+              <a:t>Provided for background</a:t>
+            </a:r>
+          </a:p>
+          <a:p>
+            <a:pPr algn="ctr"/>
+            <a:r>
+              <a:rPr lang="en-GB" sz="3200" b="1" dirty="0">
+                <a:ln w="22225">
+                  <a:solidFill>
+                    <a:schemeClr val="accent2"/>
+                  </a:solidFill>
+                  <a:prstDash val="solid"/>
+                </a:ln>
+                <a:solidFill>
+                  <a:schemeClr val="accent2">
+                    <a:lumMod val="40000"/>
+                    <a:lumOff val="60000"/>
+                  </a:schemeClr>
+                </a:solidFill>
+              </a:rPr>
+              <a:t>The material will be completed </a:t>
+            </a:r>
+          </a:p>
+          <a:p>
+            <a:pPr algn="ctr"/>
+            <a:r>
+              <a:rPr lang="en-GB" sz="3200" b="1" dirty="0">
+                <a:ln w="22225">
+                  <a:solidFill>
+                    <a:schemeClr val="accent2"/>
+                  </a:solidFill>
+                  <a:prstDash val="solid"/>
+                </a:ln>
+                <a:solidFill>
+                  <a:schemeClr val="accent2">
+                    <a:lumMod val="40000"/>
+                    <a:lumOff val="60000"/>
+                  </a:schemeClr>
+                </a:solidFill>
+              </a:rPr>
+              <a:t>and presented at a TAPI weekly call</a:t>
+            </a:r>
+          </a:p>
+        </p:txBody>
+      </p:sp>
     </p:spTree>
     <p:extLst>
       <p:ext uri="{BB962C8B-B14F-4D97-AF65-F5344CB8AC3E}">
@@ -3405,7 +3532,7 @@
 </p:sld>
 </file>
 
-<file path=ppt/slides/slide2.xml><?xml version="1.0" encoding="utf-8"?>
+<file path=ppt/slides/slide10.xml><?xml version="1.0" encoding="utf-8"?>
 <p:sld xmlns:a="http://schemas.openxmlformats.org/drawingml/2006/main" xmlns:r="http://schemas.openxmlformats.org/officeDocument/2006/relationships" xmlns:p="http://schemas.openxmlformats.org/presentationml/2006/main">
   <p:cSld>
     <p:spTree>
@@ -3424,649 +3551,6 @@
       </p:grpSpPr>
       <p:sp>
         <p:nvSpPr>
-          <p:cNvPr id="2" name="Title 1">
-            <a:extLst>
-              <a:ext uri="{FF2B5EF4-FFF2-40B4-BE49-F238E27FC236}">
-                <a16:creationId xmlns:a16="http://schemas.microsoft.com/office/drawing/2014/main" id="{068C8836-8C22-9994-20AC-54FD798009B7}"/>
-              </a:ext>
-            </a:extLst>
-          </p:cNvPr>
-          <p:cNvSpPr>
-            <a:spLocks noGrp="1"/>
-          </p:cNvSpPr>
-          <p:nvPr>
-            <p:ph type="title"/>
-          </p:nvPr>
-        </p:nvSpPr>
-        <p:spPr/>
-        <p:txBody>
-          <a:bodyPr/>
-          <a:lstStyle/>
-          <a:p>
-            <a:r>
-              <a:rPr lang="en-GB" dirty="0"/>
-              <a:t>Rough proposal</a:t>
-            </a:r>
-          </a:p>
-        </p:txBody>
-      </p:sp>
-      <p:sp>
-        <p:nvSpPr>
-          <p:cNvPr id="3" name="Content Placeholder 2">
-            <a:extLst>
-              <a:ext uri="{FF2B5EF4-FFF2-40B4-BE49-F238E27FC236}">
-                <a16:creationId xmlns:a16="http://schemas.microsoft.com/office/drawing/2014/main" id="{6F32FBF4-DFCB-2547-4BC3-C953776F28C5}"/>
-              </a:ext>
-            </a:extLst>
-          </p:cNvPr>
-          <p:cNvSpPr>
-            <a:spLocks noGrp="1"/>
-          </p:cNvSpPr>
-          <p:nvPr>
-            <p:ph idx="1"/>
-          </p:nvPr>
-        </p:nvSpPr>
-        <p:spPr/>
-        <p:txBody>
-          <a:bodyPr/>
-          <a:lstStyle/>
-          <a:p>
-            <a:r>
-              <a:rPr lang="en-GB" dirty="0"/>
-              <a:t>Use connectivity-service to create a link between two points to support a connection of the layer-rate identified</a:t>
-            </a:r>
-          </a:p>
-          <a:p>
-            <a:pPr lvl="1"/>
-            <a:r>
-              <a:rPr lang="en-GB" dirty="0"/>
-              <a:t>This is essentially requesting the connectivity service below the link and to cause a link of the selected layer with NEPs that support the identified qualifier</a:t>
-            </a:r>
-          </a:p>
-          <a:p>
-            <a:pPr lvl="1"/>
-            <a:r>
-              <a:rPr lang="en-GB" dirty="0"/>
-              <a:t>The key layer of concern has a connection in the sub-media layer</a:t>
-            </a:r>
-          </a:p>
-          <a:p>
-            <a:r>
-              <a:rPr lang="en-GB" dirty="0"/>
-              <a:t>The link details would be via “</a:t>
-            </a:r>
-            <a:r>
-              <a:rPr lang="en-GB" dirty="0" err="1"/>
-              <a:t>pacs</a:t>
-            </a:r>
-            <a:r>
-              <a:rPr lang="en-GB" dirty="0"/>
-              <a:t>” augments, taken from the link details</a:t>
-            </a:r>
-          </a:p>
-          <a:p>
-            <a:endParaRPr lang="en-GB" dirty="0"/>
-          </a:p>
-        </p:txBody>
-      </p:sp>
-    </p:spTree>
-    <p:extLst>
-      <p:ext uri="{BB962C8B-B14F-4D97-AF65-F5344CB8AC3E}">
-        <p14:creationId xmlns:p14="http://schemas.microsoft.com/office/powerpoint/2010/main" val="2263157791"/>
-      </p:ext>
-    </p:extLst>
-  </p:cSld>
-  <p:clrMapOvr>
-    <a:masterClrMapping/>
-  </p:clrMapOvr>
-</p:sld>
-</file>
-
-<file path=ppt/slides/slide3.xml><?xml version="1.0" encoding="utf-8"?>
-<p:sld xmlns:a="http://schemas.openxmlformats.org/drawingml/2006/main" xmlns:r="http://schemas.openxmlformats.org/officeDocument/2006/relationships" xmlns:p="http://schemas.openxmlformats.org/presentationml/2006/main">
-  <p:cSld>
-    <p:spTree>
-      <p:nvGrpSpPr>
-        <p:cNvPr id="1" name=""/>
-        <p:cNvGrpSpPr/>
-        <p:nvPr/>
-      </p:nvGrpSpPr>
-      <p:grpSpPr>
-        <a:xfrm>
-          <a:off x="0" y="0"/>
-          <a:ext cx="0" cy="0"/>
-          <a:chOff x="0" y="0"/>
-          <a:chExt cx="0" cy="0"/>
-        </a:xfrm>
-      </p:grpSpPr>
-      <p:sp>
-        <p:nvSpPr>
-          <p:cNvPr id="2" name="Title 1">
-            <a:extLst>
-              <a:ext uri="{FF2B5EF4-FFF2-40B4-BE49-F238E27FC236}">
-                <a16:creationId xmlns:a16="http://schemas.microsoft.com/office/drawing/2014/main" id="{DA677B2B-D4AB-43D3-6697-5E0C7425F118}"/>
-              </a:ext>
-            </a:extLst>
-          </p:cNvPr>
-          <p:cNvSpPr>
-            <a:spLocks noGrp="1"/>
-          </p:cNvSpPr>
-          <p:nvPr>
-            <p:ph type="title"/>
-          </p:nvPr>
-        </p:nvSpPr>
-        <p:spPr/>
-        <p:txBody>
-          <a:bodyPr/>
-          <a:lstStyle/>
-          <a:p>
-            <a:r>
-              <a:rPr lang="en-GB" dirty="0"/>
-              <a:t>Other connectivity-service considerations</a:t>
-            </a:r>
-          </a:p>
-        </p:txBody>
-      </p:sp>
-      <p:sp>
-        <p:nvSpPr>
-          <p:cNvPr id="3" name="Content Placeholder 2">
-            <a:extLst>
-              <a:ext uri="{FF2B5EF4-FFF2-40B4-BE49-F238E27FC236}">
-                <a16:creationId xmlns:a16="http://schemas.microsoft.com/office/drawing/2014/main" id="{DC004F9B-DC1B-E354-BAE9-2FB915798EF7}"/>
-              </a:ext>
-            </a:extLst>
-          </p:cNvPr>
-          <p:cNvSpPr>
-            <a:spLocks noGrp="1"/>
-          </p:cNvSpPr>
-          <p:nvPr>
-            <p:ph idx="1"/>
-          </p:nvPr>
-        </p:nvSpPr>
-        <p:spPr/>
-        <p:txBody>
-          <a:bodyPr>
-            <a:normAutofit fontScale="70000" lnSpcReduction="20000"/>
-          </a:bodyPr>
-          <a:lstStyle/>
-          <a:p>
-            <a:r>
-              <a:rPr lang="en-GB" dirty="0"/>
-              <a:t>Multiple services in parallel (service-set)</a:t>
-            </a:r>
-          </a:p>
-          <a:p>
-            <a:pPr lvl="1"/>
-            <a:r>
-              <a:rPr lang="en-GB" dirty="0"/>
-              <a:t>May simply be parallel creation with no subsequent association</a:t>
-            </a:r>
-          </a:p>
-          <a:p>
-            <a:pPr lvl="1"/>
-            <a:r>
-              <a:rPr lang="en-GB" dirty="0"/>
-              <a:t>May be associated in a set or other more complex structure</a:t>
-            </a:r>
-          </a:p>
-          <a:p>
-            <a:r>
-              <a:rPr lang="en-GB" dirty="0"/>
-              <a:t>Trial service returned details via streaming but not committed to the network</a:t>
-            </a:r>
-          </a:p>
-          <a:p>
-            <a:pPr lvl="1"/>
-            <a:r>
-              <a:rPr lang="en-GB" dirty="0"/>
-              <a:t>Temporary reserve of resources until service either committed to network or deleted</a:t>
-            </a:r>
-          </a:p>
-          <a:p>
-            <a:pPr lvl="1"/>
-            <a:r>
-              <a:rPr lang="en-GB" dirty="0"/>
-              <a:t>No reserve of resources beyond calculation activity (so auto delete of service)</a:t>
-            </a:r>
-          </a:p>
-          <a:p>
-            <a:pPr lvl="2"/>
-            <a:r>
-              <a:rPr lang="en-GB" dirty="0"/>
-              <a:t>Note that during the computation the resources may be acquired and then released after computation</a:t>
-            </a:r>
-          </a:p>
-          <a:p>
-            <a:r>
-              <a:rPr lang="en-GB" dirty="0"/>
-              <a:t>Timed service creation</a:t>
-            </a:r>
-          </a:p>
-          <a:p>
-            <a:pPr lvl="1"/>
-            <a:r>
-              <a:rPr lang="en-GB" dirty="0"/>
-              <a:t>With delayed commit to the network</a:t>
-            </a:r>
-          </a:p>
-          <a:p>
-            <a:pPr lvl="1"/>
-            <a:r>
-              <a:rPr lang="en-GB" dirty="0"/>
-              <a:t>With a fully fledged temporal model</a:t>
-            </a:r>
-          </a:p>
-          <a:p>
-            <a:r>
-              <a:rPr lang="en-GB" dirty="0"/>
-              <a:t>Path set creation during service creation</a:t>
-            </a:r>
-          </a:p>
-          <a:p>
-            <a:r>
-              <a:rPr lang="en-GB" dirty="0"/>
-              <a:t>Path set creation during trial service activity</a:t>
-            </a:r>
-          </a:p>
-          <a:p>
-            <a:pPr lvl="1"/>
-            <a:r>
-              <a:rPr lang="en-GB" dirty="0"/>
-              <a:t>This may be a proposed path set that is deleted after the trial or is maintained after the trial</a:t>
-            </a:r>
-          </a:p>
-          <a:p>
-            <a:r>
-              <a:rPr lang="en-GB" dirty="0"/>
-              <a:t>Multi-layer service creation (where the NEPs do not exist prior to the creation and are simply implied by the SIPs)</a:t>
-            </a:r>
-          </a:p>
-          <a:p>
-            <a:endParaRPr lang="en-GB" dirty="0"/>
-          </a:p>
-        </p:txBody>
-      </p:sp>
-    </p:spTree>
-    <p:extLst>
-      <p:ext uri="{BB962C8B-B14F-4D97-AF65-F5344CB8AC3E}">
-        <p14:creationId xmlns:p14="http://schemas.microsoft.com/office/powerpoint/2010/main" val="2742972397"/>
-      </p:ext>
-    </p:extLst>
-  </p:cSld>
-  <p:clrMapOvr>
-    <a:masterClrMapping/>
-  </p:clrMapOvr>
-</p:sld>
-</file>
-
-<file path=ppt/slides/slide4.xml><?xml version="1.0" encoding="utf-8"?>
-<p:sld xmlns:a="http://schemas.openxmlformats.org/drawingml/2006/main" xmlns:r="http://schemas.openxmlformats.org/officeDocument/2006/relationships" xmlns:p="http://schemas.openxmlformats.org/presentationml/2006/main">
-  <p:cSld>
-    <p:spTree>
-      <p:nvGrpSpPr>
-        <p:cNvPr id="1" name=""/>
-        <p:cNvGrpSpPr/>
-        <p:nvPr/>
-      </p:nvGrpSpPr>
-      <p:grpSpPr>
-        <a:xfrm>
-          <a:off x="0" y="0"/>
-          <a:ext cx="0" cy="0"/>
-          <a:chOff x="0" y="0"/>
-          <a:chExt cx="0" cy="0"/>
-        </a:xfrm>
-      </p:grpSpPr>
-      <p:sp>
-        <p:nvSpPr>
-          <p:cNvPr id="2" name="Title 1">
-            <a:extLst>
-              <a:ext uri="{FF2B5EF4-FFF2-40B4-BE49-F238E27FC236}">
-                <a16:creationId xmlns:a16="http://schemas.microsoft.com/office/drawing/2014/main" id="{98C75426-646B-F699-1844-786BF3CF3869}"/>
-              </a:ext>
-            </a:extLst>
-          </p:cNvPr>
-          <p:cNvSpPr>
-            <a:spLocks noGrp="1"/>
-          </p:cNvSpPr>
-          <p:nvPr>
-            <p:ph type="title"/>
-          </p:nvPr>
-        </p:nvSpPr>
-        <p:spPr/>
-        <p:txBody>
-          <a:bodyPr/>
-          <a:lstStyle/>
-          <a:p>
-            <a:endParaRPr lang="en-GB"/>
-          </a:p>
-        </p:txBody>
-      </p:sp>
-      <p:sp>
-        <p:nvSpPr>
-          <p:cNvPr id="3" name="Content Placeholder 2">
-            <a:extLst>
-              <a:ext uri="{FF2B5EF4-FFF2-40B4-BE49-F238E27FC236}">
-                <a16:creationId xmlns:a16="http://schemas.microsoft.com/office/drawing/2014/main" id="{20835CFB-64CE-79F9-0DF1-29E3B85B7BA3}"/>
-              </a:ext>
-            </a:extLst>
-          </p:cNvPr>
-          <p:cNvSpPr>
-            <a:spLocks noGrp="1"/>
-          </p:cNvSpPr>
-          <p:nvPr>
-            <p:ph idx="1"/>
-          </p:nvPr>
-        </p:nvSpPr>
-        <p:spPr/>
-        <p:txBody>
-          <a:bodyPr/>
-          <a:lstStyle/>
-          <a:p>
-            <a:endParaRPr lang="en-GB"/>
-          </a:p>
-        </p:txBody>
-      </p:sp>
-      <p:graphicFrame>
-        <p:nvGraphicFramePr>
-          <p:cNvPr id="4" name="Object 3">
-            <a:extLst>
-              <a:ext uri="{FF2B5EF4-FFF2-40B4-BE49-F238E27FC236}">
-                <a16:creationId xmlns:a16="http://schemas.microsoft.com/office/drawing/2014/main" id="{F34A2CB1-38D8-5E6D-637B-18487855905A}"/>
-              </a:ext>
-            </a:extLst>
-          </p:cNvPr>
-          <p:cNvGraphicFramePr>
-            <a:graphicFrameLocks noChangeAspect="1"/>
-          </p:cNvGraphicFramePr>
-          <p:nvPr>
-            <p:extLst>
-              <p:ext uri="{D42A27DB-BD31-4B8C-83A1-F6EECF244321}">
-                <p14:modId xmlns:p14="http://schemas.microsoft.com/office/powerpoint/2010/main" val="3311638835"/>
-              </p:ext>
-            </p:extLst>
-          </p:nvPr>
-        </p:nvGraphicFramePr>
-        <p:xfrm>
-          <a:off x="168828" y="340836"/>
-          <a:ext cx="11636729" cy="6545660"/>
-        </p:xfrm>
-        <a:graphic>
-          <a:graphicData uri="http://schemas.openxmlformats.org/presentationml/2006/ole">
-            <mc:AlternateContent xmlns:mc="http://schemas.openxmlformats.org/markup-compatibility/2006">
-              <mc:Choice xmlns:v="urn:schemas-microsoft-com:vml" Requires="v">
-                <p:oleObj name="Slide" r:id="rId2" imgW="6202903" imgH="3489965" progId="PowerPoint.Slide.12">
-                  <p:embed/>
-                </p:oleObj>
-              </mc:Choice>
-              <mc:Fallback>
-                <p:oleObj name="Slide" r:id="rId2" imgW="6202903" imgH="3489965" progId="PowerPoint.Slide.12">
-                  <p:embed/>
-                  <p:pic>
-                    <p:nvPicPr>
-                      <p:cNvPr id="0" name=""/>
-                      <p:cNvPicPr/>
-                      <p:nvPr/>
-                    </p:nvPicPr>
-                    <p:blipFill>
-                      <a:blip r:embed="rId3"/>
-                      <a:stretch>
-                        <a:fillRect/>
-                      </a:stretch>
-                    </p:blipFill>
-                    <p:spPr>
-                      <a:xfrm>
-                        <a:off x="168828" y="340836"/>
-                        <a:ext cx="11636729" cy="6545660"/>
-                      </a:xfrm>
-                      <a:prstGeom prst="rect">
-                        <a:avLst/>
-                      </a:prstGeom>
-                    </p:spPr>
-                  </p:pic>
-                </p:oleObj>
-              </mc:Fallback>
-            </mc:AlternateContent>
-          </a:graphicData>
-        </a:graphic>
-      </p:graphicFrame>
-      <p:sp>
-        <p:nvSpPr>
-          <p:cNvPr id="5" name="TextBox 4">
-            <a:extLst>
-              <a:ext uri="{FF2B5EF4-FFF2-40B4-BE49-F238E27FC236}">
-                <a16:creationId xmlns:a16="http://schemas.microsoft.com/office/drawing/2014/main" id="{2445E1D0-E659-0A64-542D-1B2AEBE7A4D9}"/>
-              </a:ext>
-            </a:extLst>
-          </p:cNvPr>
-          <p:cNvSpPr txBox="1"/>
-          <p:nvPr/>
-        </p:nvSpPr>
-        <p:spPr>
-          <a:xfrm>
-            <a:off x="0" y="14744"/>
-            <a:ext cx="12002004" cy="430887"/>
-          </a:xfrm>
-          <a:prstGeom prst="rect">
-            <a:avLst/>
-          </a:prstGeom>
-          <a:noFill/>
-        </p:spPr>
-        <p:txBody>
-          <a:bodyPr wrap="none" rtlCol="0">
-            <a:spAutoFit/>
-          </a:bodyPr>
-          <a:lstStyle/>
-          <a:p>
-            <a:r>
-              <a:rPr lang="en-GB" sz="1100" dirty="0">
-                <a:solidFill>
-                  <a:srgbClr val="FF0000"/>
-                </a:solidFill>
-              </a:rPr>
-              <a:t>From otcc2020.ND.010_TAPI-ConnectivityServiceComputationService </a:t>
-            </a:r>
-          </a:p>
-          <a:p>
-            <a:r>
-              <a:rPr lang="en-GB" sz="1100" dirty="0">
-                <a:solidFill>
-                  <a:srgbClr val="FF0000"/>
-                </a:solidFill>
-              </a:rPr>
-              <a:t>at https://github.com/Open-Network-Models-and-Interfaces-ONMI/TAPI-Activities/blob/main/ContributionsForDiscussions/otcc2020.ND.010_TAPI-ConnectivityServiceComputationService.pptx </a:t>
-            </a:r>
-          </a:p>
-        </p:txBody>
-      </p:sp>
-    </p:spTree>
-    <p:extLst>
-      <p:ext uri="{BB962C8B-B14F-4D97-AF65-F5344CB8AC3E}">
-        <p14:creationId xmlns:p14="http://schemas.microsoft.com/office/powerpoint/2010/main" val="1765917076"/>
-      </p:ext>
-    </p:extLst>
-  </p:cSld>
-  <p:clrMapOvr>
-    <a:masterClrMapping/>
-  </p:clrMapOvr>
-</p:sld>
-</file>
-
-<file path=ppt/slides/slide5.xml><?xml version="1.0" encoding="utf-8"?>
-<p:sld xmlns:a="http://schemas.openxmlformats.org/drawingml/2006/main" xmlns:r="http://schemas.openxmlformats.org/officeDocument/2006/relationships" xmlns:p="http://schemas.openxmlformats.org/presentationml/2006/main">
-  <p:cSld>
-    <p:spTree>
-      <p:nvGrpSpPr>
-        <p:cNvPr id="1" name=""/>
-        <p:cNvGrpSpPr/>
-        <p:nvPr/>
-      </p:nvGrpSpPr>
-      <p:grpSpPr>
-        <a:xfrm>
-          <a:off x="0" y="0"/>
-          <a:ext cx="0" cy="0"/>
-          <a:chOff x="0" y="0"/>
-          <a:chExt cx="0" cy="0"/>
-        </a:xfrm>
-      </p:grpSpPr>
-      <p:sp>
-        <p:nvSpPr>
-          <p:cNvPr id="2" name="Title 1">
-            <a:extLst>
-              <a:ext uri="{FF2B5EF4-FFF2-40B4-BE49-F238E27FC236}">
-                <a16:creationId xmlns:a16="http://schemas.microsoft.com/office/drawing/2014/main" id="{F316DB24-E5E6-6FFF-5327-04F975A1D91B}"/>
-              </a:ext>
-            </a:extLst>
-          </p:cNvPr>
-          <p:cNvSpPr>
-            <a:spLocks noGrp="1"/>
-          </p:cNvSpPr>
-          <p:nvPr>
-            <p:ph type="title"/>
-          </p:nvPr>
-        </p:nvSpPr>
-        <p:spPr/>
-        <p:txBody>
-          <a:bodyPr/>
-          <a:lstStyle/>
-          <a:p>
-            <a:r>
-              <a:rPr lang="en-GB" dirty="0"/>
-              <a:t>Complex workflows</a:t>
-            </a:r>
-          </a:p>
-        </p:txBody>
-      </p:sp>
-      <p:sp>
-        <p:nvSpPr>
-          <p:cNvPr id="3" name="Content Placeholder 2">
-            <a:extLst>
-              <a:ext uri="{FF2B5EF4-FFF2-40B4-BE49-F238E27FC236}">
-                <a16:creationId xmlns:a16="http://schemas.microsoft.com/office/drawing/2014/main" id="{376EDC27-57AA-C793-EA4F-2DCF6648D0C6}"/>
-              </a:ext>
-            </a:extLst>
-          </p:cNvPr>
-          <p:cNvSpPr>
-            <a:spLocks noGrp="1"/>
-          </p:cNvSpPr>
-          <p:nvPr>
-            <p:ph idx="1"/>
-          </p:nvPr>
-        </p:nvSpPr>
-        <p:spPr/>
-        <p:txBody>
-          <a:bodyPr>
-            <a:normAutofit fontScale="92500" lnSpcReduction="20000"/>
-          </a:bodyPr>
-          <a:lstStyle/>
-          <a:p>
-            <a:r>
-              <a:rPr lang="en-GB" dirty="0"/>
-              <a:t>Parallel simultaneous need to be built in one coherent operation</a:t>
-            </a:r>
-          </a:p>
-          <a:p>
-            <a:pPr lvl="1"/>
-            <a:r>
-              <a:rPr lang="en-GB" dirty="0"/>
-              <a:t>Choices for multi-layer build workflow are primarily proprietary</a:t>
-            </a:r>
-          </a:p>
-          <a:p>
-            <a:r>
-              <a:rPr lang="en-GB" dirty="0"/>
-              <a:t>For alternative, first alternative needs to be built then removed prior to next alternative</a:t>
-            </a:r>
-          </a:p>
-          <a:p>
-            <a:pPr lvl="1"/>
-            <a:r>
-              <a:rPr lang="en-GB" dirty="0"/>
-              <a:t>Alternatives will be streamed as built and then deleted </a:t>
-            </a:r>
-          </a:p>
-          <a:p>
-            <a:pPr lvl="2"/>
-            <a:r>
-              <a:rPr lang="en-GB" dirty="0"/>
-              <a:t>There needs to be some form of progress indication (this is essentially the progress of the task – perhaps take/enhance </a:t>
-            </a:r>
-            <a:r>
-              <a:rPr lang="en-GB" dirty="0" err="1"/>
-              <a:t>oam</a:t>
-            </a:r>
-            <a:r>
-              <a:rPr lang="en-GB" dirty="0"/>
-              <a:t>-job state and maybe even add an optional </a:t>
-            </a:r>
-            <a:r>
-              <a:rPr lang="en-GB" dirty="0" err="1"/>
-              <a:t>oam</a:t>
-            </a:r>
-            <a:r>
-              <a:rPr lang="en-GB" dirty="0"/>
-              <a:t>-jobs to connectivity-service operation)</a:t>
-            </a:r>
-          </a:p>
-          <a:p>
-            <a:r>
-              <a:rPr lang="en-GB" dirty="0"/>
-              <a:t>The “context” of the build is challenging especially where some services are expected to have been deleted prior to the requirement for the new services</a:t>
-            </a:r>
-          </a:p>
-          <a:p>
-            <a:r>
-              <a:rPr lang="en-GB" dirty="0"/>
-              <a:t>For full support</a:t>
-            </a:r>
-          </a:p>
-          <a:p>
-            <a:pPr lvl="1"/>
-            <a:r>
-              <a:rPr lang="en-GB" dirty="0"/>
-              <a:t>Needs to have temporal+ model</a:t>
-            </a:r>
-          </a:p>
-          <a:p>
-            <a:pPr lvl="1"/>
-            <a:r>
-              <a:rPr lang="en-GB" dirty="0"/>
-              <a:t>May need to provide indication of which infrastructure to use</a:t>
-            </a:r>
-          </a:p>
-        </p:txBody>
-      </p:sp>
-    </p:spTree>
-    <p:extLst>
-      <p:ext uri="{BB962C8B-B14F-4D97-AF65-F5344CB8AC3E}">
-        <p14:creationId xmlns:p14="http://schemas.microsoft.com/office/powerpoint/2010/main" val="1993011323"/>
-      </p:ext>
-    </p:extLst>
-  </p:cSld>
-  <p:clrMapOvr>
-    <a:masterClrMapping/>
-  </p:clrMapOvr>
-</p:sld>
-</file>
-
-<file path=ppt/slides/slide6.xml><?xml version="1.0" encoding="utf-8"?>
-<p:sld xmlns:a="http://schemas.openxmlformats.org/drawingml/2006/main" xmlns:r="http://schemas.openxmlformats.org/officeDocument/2006/relationships" xmlns:p="http://schemas.openxmlformats.org/presentationml/2006/main">
-  <p:cSld>
-    <p:spTree>
-      <p:nvGrpSpPr>
-        <p:cNvPr id="1" name=""/>
-        <p:cNvGrpSpPr/>
-        <p:nvPr/>
-      </p:nvGrpSpPr>
-      <p:grpSpPr>
-        <a:xfrm>
-          <a:off x="0" y="0"/>
-          <a:ext cx="0" cy="0"/>
-          <a:chOff x="0" y="0"/>
-          <a:chExt cx="0" cy="0"/>
-        </a:xfrm>
-      </p:grpSpPr>
-      <p:sp>
-        <p:nvSpPr>
           <p:cNvPr id="4" name="Title 3">
             <a:extLst>
               <a:ext uri="{FF2B5EF4-FFF2-40B4-BE49-F238E27FC236}">
@@ -4131,7 +3615,7 @@
 </p:sld>
 </file>
 
-<file path=ppt/slides/slide7.xml><?xml version="1.0" encoding="utf-8"?>
+<file path=ppt/slides/slide11.xml><?xml version="1.0" encoding="utf-8"?>
 <p:sld xmlns:a="http://schemas.openxmlformats.org/drawingml/2006/main" xmlns:r="http://schemas.openxmlformats.org/officeDocument/2006/relationships" xmlns:p="http://schemas.openxmlformats.org/presentationml/2006/main">
   <p:cSld>
     <p:spTree>
@@ -4235,7 +3719,13 @@
                   <p:embed/>
                   <p:pic>
                     <p:nvPicPr>
-                      <p:cNvPr id="0" name=""/>
+                      <p:cNvPr id="4" name="Object 3">
+                        <a:extLst>
+                          <a:ext uri="{FF2B5EF4-FFF2-40B4-BE49-F238E27FC236}">
+                            <a16:creationId xmlns:a16="http://schemas.microsoft.com/office/drawing/2014/main" id="{7C99F4E6-1CE9-968D-29E8-26BAC428E338}"/>
+                          </a:ext>
+                        </a:extLst>
+                      </p:cNvPr>
                       <p:cNvPicPr/>
                       <p:nvPr/>
                     </p:nvPicPr>
@@ -4274,7 +3764,7 @@
 </p:sld>
 </file>
 
-<file path=ppt/slides/slide8.xml><?xml version="1.0" encoding="utf-8"?>
+<file path=ppt/slides/slide12.xml><?xml version="1.0" encoding="utf-8"?>
 <p:sld xmlns:a="http://schemas.openxmlformats.org/drawingml/2006/main" xmlns:r="http://schemas.openxmlformats.org/officeDocument/2006/relationships" xmlns:p="http://schemas.openxmlformats.org/presentationml/2006/main">
   <p:cSld>
     <p:spTree>
@@ -4363,6 +3853,2151 @@
     <p:extLst>
       <p:ext uri="{BB962C8B-B14F-4D97-AF65-F5344CB8AC3E}">
         <p14:creationId xmlns:p14="http://schemas.microsoft.com/office/powerpoint/2010/main" val="2146489845"/>
+      </p:ext>
+    </p:extLst>
+  </p:cSld>
+  <p:clrMapOvr>
+    <a:masterClrMapping/>
+  </p:clrMapOvr>
+</p:sld>
+</file>
+
+<file path=ppt/slides/slide13.xml><?xml version="1.0" encoding="utf-8"?>
+<p:sld xmlns:a="http://schemas.openxmlformats.org/drawingml/2006/main" xmlns:r="http://schemas.openxmlformats.org/officeDocument/2006/relationships" xmlns:p="http://schemas.openxmlformats.org/presentationml/2006/main">
+  <p:cSld>
+    <p:spTree>
+      <p:nvGrpSpPr>
+        <p:cNvPr id="1" name=""/>
+        <p:cNvGrpSpPr/>
+        <p:nvPr/>
+      </p:nvGrpSpPr>
+      <p:grpSpPr>
+        <a:xfrm>
+          <a:off x="0" y="0"/>
+          <a:ext cx="0" cy="0"/>
+          <a:chOff x="0" y="0"/>
+          <a:chExt cx="0" cy="0"/>
+        </a:xfrm>
+      </p:grpSpPr>
+      <p:sp>
+        <p:nvSpPr>
+          <p:cNvPr id="2" name="Title 1">
+            <a:extLst>
+              <a:ext uri="{FF2B5EF4-FFF2-40B4-BE49-F238E27FC236}">
+                <a16:creationId xmlns:a16="http://schemas.microsoft.com/office/drawing/2014/main" id="{FCBFA27E-E077-8A0A-389A-66EF78FFB755}"/>
+              </a:ext>
+            </a:extLst>
+          </p:cNvPr>
+          <p:cNvSpPr>
+            <a:spLocks noGrp="1"/>
+          </p:cNvSpPr>
+          <p:nvPr>
+            <p:ph type="title"/>
+          </p:nvPr>
+        </p:nvSpPr>
+        <p:spPr/>
+        <p:txBody>
+          <a:bodyPr/>
+          <a:lstStyle/>
+          <a:p>
+            <a:r>
+              <a:rPr lang="en-GB" dirty="0"/>
+              <a:t>Sketch of states</a:t>
+            </a:r>
+          </a:p>
+        </p:txBody>
+      </p:sp>
+      <p:sp>
+        <p:nvSpPr>
+          <p:cNvPr id="3" name="Content Placeholder 2">
+            <a:extLst>
+              <a:ext uri="{FF2B5EF4-FFF2-40B4-BE49-F238E27FC236}">
+                <a16:creationId xmlns:a16="http://schemas.microsoft.com/office/drawing/2014/main" id="{FC42815C-93D2-DF8E-BFAC-04B663B7E806}"/>
+              </a:ext>
+            </a:extLst>
+          </p:cNvPr>
+          <p:cNvSpPr>
+            <a:spLocks noGrp="1"/>
+          </p:cNvSpPr>
+          <p:nvPr>
+            <p:ph idx="1"/>
+          </p:nvPr>
+        </p:nvSpPr>
+        <p:spPr/>
+        <p:txBody>
+          <a:bodyPr>
+            <a:normAutofit fontScale="77500" lnSpcReduction="20000"/>
+          </a:bodyPr>
+          <a:lstStyle/>
+          <a:p>
+            <a:pPr>
+              <a:lnSpc>
+                <a:spcPct val="120000"/>
+              </a:lnSpc>
+              <a:spcBef>
+                <a:spcPts val="100"/>
+              </a:spcBef>
+              <a:spcAft>
+                <a:spcPts val="800"/>
+              </a:spcAft>
+              <a:buNone/>
+            </a:pPr>
+            <a:r>
+              <a:rPr lang="en-GB" sz="1800" kern="100" dirty="0">
+                <a:effectLst/>
+                <a:latin typeface="Aptos" panose="020B0004020202020204" pitchFamily="34" charset="0"/>
+                <a:ea typeface="Aptos" panose="020B0004020202020204" pitchFamily="34" charset="0"/>
+                <a:cs typeface="Times New Roman" panose="02020603050405020304" pitchFamily="18" charset="0"/>
+              </a:rPr>
+              <a:t>PARTIALLY_DEFINED – Path computation has not run, is running or has run but viability validation is required</a:t>
+            </a:r>
+          </a:p>
+          <a:p>
+            <a:pPr>
+              <a:lnSpc>
+                <a:spcPct val="120000"/>
+              </a:lnSpc>
+              <a:spcBef>
+                <a:spcPts val="100"/>
+              </a:spcBef>
+              <a:spcAft>
+                <a:spcPts val="800"/>
+              </a:spcAft>
+              <a:buNone/>
+            </a:pPr>
+            <a:r>
+              <a:rPr lang="en-GB" sz="1800" kern="100" dirty="0">
+                <a:effectLst/>
+                <a:latin typeface="Aptos" panose="020B0004020202020204" pitchFamily="34" charset="0"/>
+                <a:ea typeface="Aptos" panose="020B0004020202020204" pitchFamily="34" charset="0"/>
+                <a:cs typeface="Times New Roman" panose="02020603050405020304" pitchFamily="18" charset="0"/>
+              </a:rPr>
+              <a:t>DEFINED_AND_VIABLE – Path computation has run and viability has been validated</a:t>
+            </a:r>
+          </a:p>
+          <a:p>
+            <a:pPr>
+              <a:lnSpc>
+                <a:spcPct val="120000"/>
+              </a:lnSpc>
+              <a:spcBef>
+                <a:spcPts val="100"/>
+              </a:spcBef>
+              <a:spcAft>
+                <a:spcPts val="800"/>
+              </a:spcAft>
+              <a:buNone/>
+            </a:pPr>
+            <a:r>
+              <a:rPr lang="en-GB" sz="1800" kern="100" dirty="0">
+                <a:effectLst/>
+                <a:latin typeface="Aptos" panose="020B0004020202020204" pitchFamily="34" charset="0"/>
+                <a:ea typeface="Aptos" panose="020B0004020202020204" pitchFamily="34" charset="0"/>
+                <a:cs typeface="Times New Roman" panose="02020603050405020304" pitchFamily="18" charset="0"/>
+              </a:rPr>
+              <a:t>READY_TO_DEPLOY – All connections and termination properties have been prepared, and deployment can now take place</a:t>
+            </a:r>
+          </a:p>
+          <a:p>
+            <a:pPr>
+              <a:lnSpc>
+                <a:spcPct val="120000"/>
+              </a:lnSpc>
+              <a:spcBef>
+                <a:spcPts val="100"/>
+              </a:spcBef>
+              <a:spcAft>
+                <a:spcPts val="800"/>
+              </a:spcAft>
+              <a:buNone/>
+            </a:pPr>
+            <a:r>
+              <a:rPr lang="en-GB" sz="1800" kern="100" dirty="0">
+                <a:effectLst/>
+                <a:latin typeface="Aptos" panose="020B0004020202020204" pitchFamily="34" charset="0"/>
+                <a:ea typeface="Aptos" panose="020B0004020202020204" pitchFamily="34" charset="0"/>
+                <a:cs typeface="Times New Roman" panose="02020603050405020304" pitchFamily="18" charset="0"/>
+              </a:rPr>
+              <a:t>DEPLOYMENT_IN_PROGRESS – Network provisioning is underway</a:t>
+            </a:r>
+          </a:p>
+          <a:p>
+            <a:pPr>
+              <a:lnSpc>
+                <a:spcPct val="120000"/>
+              </a:lnSpc>
+              <a:spcBef>
+                <a:spcPts val="100"/>
+              </a:spcBef>
+              <a:spcAft>
+                <a:spcPts val="800"/>
+              </a:spcAft>
+              <a:buNone/>
+            </a:pPr>
+            <a:r>
+              <a:rPr lang="en-GB" sz="1800" kern="100" dirty="0">
+                <a:effectLst/>
+                <a:latin typeface="Aptos" panose="020B0004020202020204" pitchFamily="34" charset="0"/>
+                <a:ea typeface="Aptos" panose="020B0004020202020204" pitchFamily="34" charset="0"/>
+                <a:cs typeface="Times New Roman" panose="02020603050405020304" pitchFamily="18" charset="0"/>
+              </a:rPr>
+              <a:t>INCOMPLETE_DEPLOYMENT – Deployment was not successful</a:t>
+            </a:r>
+          </a:p>
+          <a:p>
+            <a:pPr>
+              <a:lnSpc>
+                <a:spcPct val="120000"/>
+              </a:lnSpc>
+              <a:spcBef>
+                <a:spcPts val="100"/>
+              </a:spcBef>
+              <a:spcAft>
+                <a:spcPts val="800"/>
+              </a:spcAft>
+              <a:buNone/>
+            </a:pPr>
+            <a:r>
+              <a:rPr lang="en-GB" sz="1800" kern="100" dirty="0">
+                <a:effectLst/>
+                <a:latin typeface="Aptos" panose="020B0004020202020204" pitchFamily="34" charset="0"/>
+                <a:ea typeface="Aptos" panose="020B0004020202020204" pitchFamily="34" charset="0"/>
+                <a:cs typeface="Times New Roman" panose="02020603050405020304" pitchFamily="18" charset="0"/>
+              </a:rPr>
+              <a:t>INCOMPLETE_NOT_READY – Deployment was successful but something else is preventing completion</a:t>
+            </a:r>
+          </a:p>
+          <a:p>
+            <a:pPr>
+              <a:lnSpc>
+                <a:spcPct val="120000"/>
+              </a:lnSpc>
+              <a:spcBef>
+                <a:spcPts val="100"/>
+              </a:spcBef>
+              <a:spcAft>
+                <a:spcPts val="800"/>
+              </a:spcAft>
+              <a:buNone/>
+            </a:pPr>
+            <a:r>
+              <a:rPr lang="en-GB" sz="1800" kern="100" dirty="0">
+                <a:effectLst/>
+                <a:latin typeface="Aptos" panose="020B0004020202020204" pitchFamily="34" charset="0"/>
+                <a:ea typeface="Aptos" panose="020B0004020202020204" pitchFamily="34" charset="0"/>
+                <a:cs typeface="Times New Roman" panose="02020603050405020304" pitchFamily="18" charset="0"/>
+              </a:rPr>
+              <a:t>INCOMPLETE_NOT_READY_CONFLICT – Deployment conflicts with other services</a:t>
+            </a:r>
+          </a:p>
+          <a:p>
+            <a:pPr>
+              <a:lnSpc>
+                <a:spcPct val="120000"/>
+              </a:lnSpc>
+              <a:spcBef>
+                <a:spcPts val="100"/>
+              </a:spcBef>
+              <a:spcAft>
+                <a:spcPts val="800"/>
+              </a:spcAft>
+              <a:buNone/>
+            </a:pPr>
+            <a:r>
+              <a:rPr lang="en-GB" sz="1800" kern="100" dirty="0">
+                <a:effectLst/>
+                <a:latin typeface="Aptos" panose="020B0004020202020204" pitchFamily="34" charset="0"/>
+                <a:ea typeface="Aptos" panose="020B0004020202020204" pitchFamily="34" charset="0"/>
+                <a:cs typeface="Times New Roman" panose="02020603050405020304" pitchFamily="18" charset="0"/>
+              </a:rPr>
+              <a:t>INCOMPLETE_READY_BEST_EFFORT – something </a:t>
+            </a:r>
+            <a:r>
+              <a:rPr lang="en-GB" sz="1800" kern="100" dirty="0">
+                <a:latin typeface="Aptos" panose="020B0004020202020204" pitchFamily="34" charset="0"/>
+                <a:ea typeface="Aptos" panose="020B0004020202020204" pitchFamily="34" charset="0"/>
+                <a:cs typeface="Times New Roman" panose="02020603050405020304" pitchFamily="18" charset="0"/>
+              </a:rPr>
+              <a:t>did not complete but sufficient is in place to carry traffic</a:t>
+            </a:r>
+            <a:endParaRPr lang="en-GB" sz="1800" kern="100" dirty="0">
+              <a:effectLst/>
+              <a:latin typeface="Aptos" panose="020B0004020202020204" pitchFamily="34" charset="0"/>
+              <a:ea typeface="Aptos" panose="020B0004020202020204" pitchFamily="34" charset="0"/>
+              <a:cs typeface="Times New Roman" panose="02020603050405020304" pitchFamily="18" charset="0"/>
+            </a:endParaRPr>
+          </a:p>
+          <a:p>
+            <a:pPr>
+              <a:lnSpc>
+                <a:spcPct val="120000"/>
+              </a:lnSpc>
+              <a:spcBef>
+                <a:spcPts val="100"/>
+              </a:spcBef>
+              <a:spcAft>
+                <a:spcPts val="800"/>
+              </a:spcAft>
+              <a:buNone/>
+            </a:pPr>
+            <a:r>
+              <a:rPr lang="en-GB" sz="1800" kern="100" dirty="0">
+                <a:effectLst/>
+                <a:latin typeface="Aptos" panose="020B0004020202020204" pitchFamily="34" charset="0"/>
+                <a:ea typeface="Aptos" panose="020B0004020202020204" pitchFamily="34" charset="0"/>
+                <a:cs typeface="Times New Roman" panose="02020603050405020304" pitchFamily="18" charset="0"/>
+              </a:rPr>
+              <a:t>COMPLETE_FULLY_READY – Ready to carry traffic</a:t>
+            </a:r>
+          </a:p>
+          <a:p>
+            <a:pPr>
+              <a:lnSpc>
+                <a:spcPct val="120000"/>
+              </a:lnSpc>
+              <a:spcBef>
+                <a:spcPts val="100"/>
+              </a:spcBef>
+              <a:spcAft>
+                <a:spcPts val="800"/>
+              </a:spcAft>
+              <a:buNone/>
+            </a:pPr>
+            <a:r>
+              <a:rPr lang="en-GB" sz="1800" kern="100" dirty="0">
+                <a:effectLst/>
+                <a:latin typeface="Aptos" panose="020B0004020202020204" pitchFamily="34" charset="0"/>
+                <a:ea typeface="Aptos" panose="020B0004020202020204" pitchFamily="34" charset="0"/>
+                <a:cs typeface="Times New Roman" panose="02020603050405020304" pitchFamily="18" charset="0"/>
+              </a:rPr>
+              <a:t>UNDEPLOYMENT_IN_PROGRESS – removal of connections from the network is underway</a:t>
+            </a:r>
+          </a:p>
+          <a:p>
+            <a:pPr>
+              <a:lnSpc>
+                <a:spcPct val="120000"/>
+              </a:lnSpc>
+              <a:spcBef>
+                <a:spcPts val="100"/>
+              </a:spcBef>
+              <a:spcAft>
+                <a:spcPts val="800"/>
+              </a:spcAft>
+              <a:buNone/>
+            </a:pPr>
+            <a:r>
+              <a:rPr lang="en-GB" sz="1800" kern="100" dirty="0">
+                <a:effectLst/>
+                <a:latin typeface="Aptos" panose="020B0004020202020204" pitchFamily="34" charset="0"/>
+                <a:ea typeface="Aptos" panose="020B0004020202020204" pitchFamily="34" charset="0"/>
+                <a:cs typeface="Times New Roman" panose="02020603050405020304" pitchFamily="18" charset="0"/>
+              </a:rPr>
+              <a:t>INCOMPLETE_UNDEPLOYMENT – some connections could not be removed</a:t>
+            </a:r>
+          </a:p>
+          <a:p>
+            <a:pPr>
+              <a:lnSpc>
+                <a:spcPct val="120000"/>
+              </a:lnSpc>
+              <a:spcBef>
+                <a:spcPts val="100"/>
+              </a:spcBef>
+              <a:spcAft>
+                <a:spcPts val="800"/>
+              </a:spcAft>
+              <a:buNone/>
+            </a:pPr>
+            <a:r>
+              <a:rPr lang="en-GB" sz="1800" kern="100" dirty="0">
+                <a:effectLst/>
+                <a:latin typeface="Aptos" panose="020B0004020202020204" pitchFamily="34" charset="0"/>
+                <a:ea typeface="Aptos" panose="020B0004020202020204" pitchFamily="34" charset="0"/>
+                <a:cs typeface="Times New Roman" panose="02020603050405020304" pitchFamily="18" charset="0"/>
+              </a:rPr>
+              <a:t>UNDEPLOYED – there are no connections in the network</a:t>
+            </a:r>
+          </a:p>
+          <a:p>
+            <a:pPr>
+              <a:lnSpc>
+                <a:spcPct val="120000"/>
+              </a:lnSpc>
+              <a:spcBef>
+                <a:spcPts val="100"/>
+              </a:spcBef>
+              <a:spcAft>
+                <a:spcPts val="800"/>
+              </a:spcAft>
+              <a:buNone/>
+            </a:pPr>
+            <a:r>
+              <a:rPr lang="en-GB" sz="1800" kern="100" dirty="0">
+                <a:effectLst/>
+                <a:latin typeface="Aptos" panose="020B0004020202020204" pitchFamily="34" charset="0"/>
+                <a:ea typeface="Aptos" panose="020B0004020202020204" pitchFamily="34" charset="0"/>
+                <a:cs typeface="Times New Roman" panose="02020603050405020304" pitchFamily="18" charset="0"/>
+              </a:rPr>
+              <a:t>WAITING_TO_ADOPT </a:t>
+            </a:r>
+          </a:p>
+        </p:txBody>
+      </p:sp>
+    </p:spTree>
+    <p:extLst>
+      <p:ext uri="{BB962C8B-B14F-4D97-AF65-F5344CB8AC3E}">
+        <p14:creationId xmlns:p14="http://schemas.microsoft.com/office/powerpoint/2010/main" val="82091154"/>
+      </p:ext>
+    </p:extLst>
+  </p:cSld>
+  <p:clrMapOvr>
+    <a:masterClrMapping/>
+  </p:clrMapOvr>
+</p:sld>
+</file>
+
+<file path=ppt/slides/slide2.xml><?xml version="1.0" encoding="utf-8"?>
+<p:sld xmlns:a="http://schemas.openxmlformats.org/drawingml/2006/main" xmlns:r="http://schemas.openxmlformats.org/officeDocument/2006/relationships" xmlns:p="http://schemas.openxmlformats.org/presentationml/2006/main">
+  <p:cSld>
+    <p:spTree>
+      <p:nvGrpSpPr>
+        <p:cNvPr id="1" name=""/>
+        <p:cNvGrpSpPr/>
+        <p:nvPr/>
+      </p:nvGrpSpPr>
+      <p:grpSpPr>
+        <a:xfrm>
+          <a:off x="0" y="0"/>
+          <a:ext cx="0" cy="0"/>
+          <a:chOff x="0" y="0"/>
+          <a:chExt cx="0" cy="0"/>
+        </a:xfrm>
+      </p:grpSpPr>
+      <p:sp>
+        <p:nvSpPr>
+          <p:cNvPr id="2" name="Title 1">
+            <a:extLst>
+              <a:ext uri="{FF2B5EF4-FFF2-40B4-BE49-F238E27FC236}">
+                <a16:creationId xmlns:a16="http://schemas.microsoft.com/office/drawing/2014/main" id="{068C8836-8C22-9994-20AC-54FD798009B7}"/>
+              </a:ext>
+            </a:extLst>
+          </p:cNvPr>
+          <p:cNvSpPr>
+            <a:spLocks noGrp="1"/>
+          </p:cNvSpPr>
+          <p:nvPr>
+            <p:ph type="title"/>
+          </p:nvPr>
+        </p:nvSpPr>
+        <p:spPr/>
+        <p:txBody>
+          <a:bodyPr/>
+          <a:lstStyle/>
+          <a:p>
+            <a:r>
+              <a:rPr lang="en-GB" dirty="0"/>
+              <a:t>Rough proposal</a:t>
+            </a:r>
+          </a:p>
+        </p:txBody>
+      </p:sp>
+      <p:sp>
+        <p:nvSpPr>
+          <p:cNvPr id="3" name="Content Placeholder 2">
+            <a:extLst>
+              <a:ext uri="{FF2B5EF4-FFF2-40B4-BE49-F238E27FC236}">
+                <a16:creationId xmlns:a16="http://schemas.microsoft.com/office/drawing/2014/main" id="{6F32FBF4-DFCB-2547-4BC3-C953776F28C5}"/>
+              </a:ext>
+            </a:extLst>
+          </p:cNvPr>
+          <p:cNvSpPr>
+            <a:spLocks noGrp="1"/>
+          </p:cNvSpPr>
+          <p:nvPr>
+            <p:ph idx="1"/>
+          </p:nvPr>
+        </p:nvSpPr>
+        <p:spPr/>
+        <p:txBody>
+          <a:bodyPr/>
+          <a:lstStyle/>
+          <a:p>
+            <a:r>
+              <a:rPr lang="en-GB" dirty="0"/>
+              <a:t>Use connectivity-service to create a link between two points to support a connection of the layer-rate identified</a:t>
+            </a:r>
+          </a:p>
+          <a:p>
+            <a:pPr lvl="1"/>
+            <a:r>
+              <a:rPr lang="en-GB" dirty="0"/>
+              <a:t>This is essentially requesting the connectivity service below the link and to cause a link of the selected layer with NEPs that support the identified qualifier</a:t>
+            </a:r>
+          </a:p>
+          <a:p>
+            <a:pPr lvl="1"/>
+            <a:r>
+              <a:rPr lang="en-GB" dirty="0"/>
+              <a:t>The key layer of concern has a connection in the sub-media layer</a:t>
+            </a:r>
+          </a:p>
+          <a:p>
+            <a:r>
+              <a:rPr lang="en-GB" dirty="0"/>
+              <a:t>The link details would be via “</a:t>
+            </a:r>
+            <a:r>
+              <a:rPr lang="en-GB" dirty="0" err="1"/>
+              <a:t>pacs</a:t>
+            </a:r>
+            <a:r>
+              <a:rPr lang="en-GB" dirty="0"/>
+              <a:t>” augments, taken from the link details</a:t>
+            </a:r>
+          </a:p>
+          <a:p>
+            <a:endParaRPr lang="en-GB" dirty="0"/>
+          </a:p>
+        </p:txBody>
+      </p:sp>
+    </p:spTree>
+    <p:extLst>
+      <p:ext uri="{BB962C8B-B14F-4D97-AF65-F5344CB8AC3E}">
+        <p14:creationId xmlns:p14="http://schemas.microsoft.com/office/powerpoint/2010/main" val="2263157791"/>
+      </p:ext>
+    </p:extLst>
+  </p:cSld>
+  <p:clrMapOvr>
+    <a:masterClrMapping/>
+  </p:clrMapOvr>
+</p:sld>
+</file>
+
+<file path=ppt/slides/slide3.xml><?xml version="1.0" encoding="utf-8"?>
+<p:sld xmlns:a="http://schemas.openxmlformats.org/drawingml/2006/main" xmlns:r="http://schemas.openxmlformats.org/officeDocument/2006/relationships" xmlns:p="http://schemas.openxmlformats.org/presentationml/2006/main">
+  <p:cSld>
+    <p:spTree>
+      <p:nvGrpSpPr>
+        <p:cNvPr id="1" name=""/>
+        <p:cNvGrpSpPr/>
+        <p:nvPr/>
+      </p:nvGrpSpPr>
+      <p:grpSpPr>
+        <a:xfrm>
+          <a:off x="0" y="0"/>
+          <a:ext cx="0" cy="0"/>
+          <a:chOff x="0" y="0"/>
+          <a:chExt cx="0" cy="0"/>
+        </a:xfrm>
+      </p:grpSpPr>
+      <p:sp>
+        <p:nvSpPr>
+          <p:cNvPr id="2" name="Title 1">
+            <a:extLst>
+              <a:ext uri="{FF2B5EF4-FFF2-40B4-BE49-F238E27FC236}">
+                <a16:creationId xmlns:a16="http://schemas.microsoft.com/office/drawing/2014/main" id="{3B127412-D46B-A6CC-CF35-38054D71E5F6}"/>
+              </a:ext>
+            </a:extLst>
+          </p:cNvPr>
+          <p:cNvSpPr>
+            <a:spLocks noGrp="1"/>
+          </p:cNvSpPr>
+          <p:nvPr>
+            <p:ph type="title"/>
+          </p:nvPr>
+        </p:nvSpPr>
+        <p:spPr>
+          <a:xfrm>
+            <a:off x="838200" y="116541"/>
+            <a:ext cx="10515600" cy="564497"/>
+          </a:xfrm>
+        </p:spPr>
+        <p:txBody>
+          <a:bodyPr>
+            <a:normAutofit fontScale="90000"/>
+          </a:bodyPr>
+          <a:lstStyle/>
+          <a:p>
+            <a:r>
+              <a:rPr lang="en-GB" dirty="0"/>
+              <a:t>Analysis of TAPI 2.6 – Link</a:t>
+            </a:r>
+          </a:p>
+        </p:txBody>
+      </p:sp>
+      <p:graphicFrame>
+        <p:nvGraphicFramePr>
+          <p:cNvPr id="6" name="Object 5">
+            <a:extLst>
+              <a:ext uri="{FF2B5EF4-FFF2-40B4-BE49-F238E27FC236}">
+                <a16:creationId xmlns:a16="http://schemas.microsoft.com/office/drawing/2014/main" id="{389E7DB2-5EF2-1829-7263-7B91D18959A1}"/>
+              </a:ext>
+            </a:extLst>
+          </p:cNvPr>
+          <p:cNvGraphicFramePr>
+            <a:graphicFrameLocks noChangeAspect="1"/>
+          </p:cNvGraphicFramePr>
+          <p:nvPr>
+            <p:extLst>
+              <p:ext uri="{D42A27DB-BD31-4B8C-83A1-F6EECF244321}">
+                <p14:modId xmlns:p14="http://schemas.microsoft.com/office/powerpoint/2010/main" val="1383685124"/>
+              </p:ext>
+            </p:extLst>
+          </p:nvPr>
+        </p:nvGraphicFramePr>
+        <p:xfrm>
+          <a:off x="219075" y="639763"/>
+          <a:ext cx="6145213" cy="6145212"/>
+        </p:xfrm>
+        <a:graphic>
+          <a:graphicData uri="http://schemas.openxmlformats.org/presentationml/2006/ole">
+            <mc:AlternateContent xmlns:mc="http://schemas.openxmlformats.org/markup-compatibility/2006">
+              <mc:Choice xmlns:v="urn:schemas-microsoft-com:vml" Requires="v">
+                <p:oleObj name="Slide" r:id="rId2" imgW="3649952" imgH="3650171" progId="PowerPoint.Slide.12">
+                  <p:embed/>
+                </p:oleObj>
+              </mc:Choice>
+              <mc:Fallback>
+                <p:oleObj name="Slide" r:id="rId2" imgW="3649952" imgH="3650171" progId="PowerPoint.Slide.12">
+                  <p:embed/>
+                  <p:pic>
+                    <p:nvPicPr>
+                      <p:cNvPr id="0" name=""/>
+                      <p:cNvPicPr/>
+                      <p:nvPr/>
+                    </p:nvPicPr>
+                    <p:blipFill>
+                      <a:blip r:embed="rId3"/>
+                      <a:stretch>
+                        <a:fillRect/>
+                      </a:stretch>
+                    </p:blipFill>
+                    <p:spPr>
+                      <a:xfrm>
+                        <a:off x="219075" y="639763"/>
+                        <a:ext cx="6145213" cy="6145212"/>
+                      </a:xfrm>
+                      <a:prstGeom prst="rect">
+                        <a:avLst/>
+                      </a:prstGeom>
+                    </p:spPr>
+                  </p:pic>
+                </p:oleObj>
+              </mc:Fallback>
+            </mc:AlternateContent>
+          </a:graphicData>
+        </a:graphic>
+      </p:graphicFrame>
+      <p:sp>
+        <p:nvSpPr>
+          <p:cNvPr id="7" name="TextBox 6">
+            <a:extLst>
+              <a:ext uri="{FF2B5EF4-FFF2-40B4-BE49-F238E27FC236}">
+                <a16:creationId xmlns:a16="http://schemas.microsoft.com/office/drawing/2014/main" id="{20475FD4-A83A-693A-ED1D-65D268F4AC35}"/>
+              </a:ext>
+            </a:extLst>
+          </p:cNvPr>
+          <p:cNvSpPr txBox="1"/>
+          <p:nvPr/>
+        </p:nvSpPr>
+        <p:spPr>
+          <a:xfrm>
+            <a:off x="6553202" y="855989"/>
+            <a:ext cx="4876800" cy="1754326"/>
+          </a:xfrm>
+          <a:prstGeom prst="rect">
+            <a:avLst/>
+          </a:prstGeom>
+          <a:noFill/>
+        </p:spPr>
+        <p:txBody>
+          <a:bodyPr wrap="square" rtlCol="0">
+            <a:spAutoFit/>
+          </a:bodyPr>
+          <a:lstStyle/>
+          <a:p>
+            <a:r>
+              <a:rPr lang="en-GB" sz="1200" dirty="0"/>
+              <a:t>Observations – link </a:t>
+            </a:r>
+          </a:p>
+          <a:p>
+            <a:pPr marL="285750" indent="-285750">
+              <a:buFont typeface="Arial" panose="020B0604020202020204" pitchFamily="34" charset="0"/>
+              <a:buChar char="•"/>
+            </a:pPr>
+            <a:r>
+              <a:rPr lang="en-GB" sz="1200" dirty="0"/>
+              <a:t>Direction missing from node-edge-point</a:t>
+            </a:r>
+          </a:p>
+          <a:p>
+            <a:pPr marL="742950" lvl="1" indent="-285750">
+              <a:buFont typeface="Arial" panose="020B0604020202020204" pitchFamily="34" charset="0"/>
+              <a:buChar char="•"/>
+            </a:pPr>
+            <a:r>
+              <a:rPr lang="en-GB" sz="1200" dirty="0"/>
+              <a:t>Asymmetric links are not possible although asymmetric connections are (according to connectivity-service)</a:t>
+            </a:r>
+          </a:p>
+          <a:p>
+            <a:pPr marL="1200150" lvl="2" indent="-285750">
+              <a:buFont typeface="Arial" panose="020B0604020202020204" pitchFamily="34" charset="0"/>
+              <a:buChar char="•"/>
+            </a:pPr>
+            <a:r>
+              <a:rPr lang="en-GB" sz="1200" dirty="0"/>
+              <a:t>Link should match connection!</a:t>
+            </a:r>
+          </a:p>
+          <a:p>
+            <a:pPr marL="285750" indent="-285750">
+              <a:buFont typeface="Arial" panose="020B0604020202020204" pitchFamily="34" charset="0"/>
+              <a:buChar char="•"/>
+            </a:pPr>
+            <a:r>
+              <a:rPr lang="en-GB" sz="1200" dirty="0"/>
+              <a:t>Capacity on link is on whole link yet on service it is on endpoint</a:t>
+            </a:r>
+          </a:p>
+          <a:p>
+            <a:pPr marL="742950" lvl="1" indent="-285750">
+              <a:buFont typeface="Arial" panose="020B0604020202020204" pitchFamily="34" charset="0"/>
+              <a:buChar char="•"/>
+            </a:pPr>
+            <a:r>
+              <a:rPr lang="en-GB" sz="1200" dirty="0"/>
+              <a:t>Service is more correct in that in an asymmetric multi-point situation the emergent link would have different capacities at each end (this is not as relevant for photonics as IP)</a:t>
+            </a:r>
+          </a:p>
+        </p:txBody>
+      </p:sp>
+    </p:spTree>
+    <p:extLst>
+      <p:ext uri="{BB962C8B-B14F-4D97-AF65-F5344CB8AC3E}">
+        <p14:creationId xmlns:p14="http://schemas.microsoft.com/office/powerpoint/2010/main" val="2321124855"/>
+      </p:ext>
+    </p:extLst>
+  </p:cSld>
+  <p:clrMapOvr>
+    <a:masterClrMapping/>
+  </p:clrMapOvr>
+</p:sld>
+</file>
+
+<file path=ppt/slides/slide4.xml><?xml version="1.0" encoding="utf-8"?>
+<p:sld xmlns:a="http://schemas.openxmlformats.org/drawingml/2006/main" xmlns:r="http://schemas.openxmlformats.org/officeDocument/2006/relationships" xmlns:p="http://schemas.openxmlformats.org/presentationml/2006/main">
+  <p:cSld>
+    <p:spTree>
+      <p:nvGrpSpPr>
+        <p:cNvPr id="1" name="">
+          <a:extLst>
+            <a:ext uri="{FF2B5EF4-FFF2-40B4-BE49-F238E27FC236}">
+              <a16:creationId xmlns:a16="http://schemas.microsoft.com/office/drawing/2014/main" id="{E3BDCD98-60C8-3E67-7C58-075C6FC8F0AA}"/>
+            </a:ext>
+          </a:extLst>
+        </p:cNvPr>
+        <p:cNvGrpSpPr/>
+        <p:nvPr/>
+      </p:nvGrpSpPr>
+      <p:grpSpPr>
+        <a:xfrm>
+          <a:off x="0" y="0"/>
+          <a:ext cx="0" cy="0"/>
+          <a:chOff x="0" y="0"/>
+          <a:chExt cx="0" cy="0"/>
+        </a:xfrm>
+      </p:grpSpPr>
+      <p:sp>
+        <p:nvSpPr>
+          <p:cNvPr id="2" name="Title 1">
+            <a:extLst>
+              <a:ext uri="{FF2B5EF4-FFF2-40B4-BE49-F238E27FC236}">
+                <a16:creationId xmlns:a16="http://schemas.microsoft.com/office/drawing/2014/main" id="{73644C52-FCE2-D902-9F88-AF5BE767E7D0}"/>
+              </a:ext>
+            </a:extLst>
+          </p:cNvPr>
+          <p:cNvSpPr>
+            <a:spLocks noGrp="1"/>
+          </p:cNvSpPr>
+          <p:nvPr>
+            <p:ph type="title"/>
+          </p:nvPr>
+        </p:nvSpPr>
+        <p:spPr>
+          <a:xfrm>
+            <a:off x="838200" y="116541"/>
+            <a:ext cx="10515600" cy="564497"/>
+          </a:xfrm>
+        </p:spPr>
+        <p:txBody>
+          <a:bodyPr>
+            <a:normAutofit fontScale="90000"/>
+          </a:bodyPr>
+          <a:lstStyle/>
+          <a:p>
+            <a:r>
+              <a:rPr lang="en-GB" dirty="0"/>
+              <a:t>Analysis of TAPI 2.6 – connectivity-service</a:t>
+            </a:r>
+          </a:p>
+        </p:txBody>
+      </p:sp>
+      <p:graphicFrame>
+        <p:nvGraphicFramePr>
+          <p:cNvPr id="3" name="Object 2">
+            <a:extLst>
+              <a:ext uri="{FF2B5EF4-FFF2-40B4-BE49-F238E27FC236}">
+                <a16:creationId xmlns:a16="http://schemas.microsoft.com/office/drawing/2014/main" id="{EABBB842-C195-C44C-DFF0-82E5CB83DB4C}"/>
+              </a:ext>
+            </a:extLst>
+          </p:cNvPr>
+          <p:cNvGraphicFramePr>
+            <a:graphicFrameLocks noChangeAspect="1"/>
+          </p:cNvGraphicFramePr>
+          <p:nvPr>
+            <p:extLst>
+              <p:ext uri="{D42A27DB-BD31-4B8C-83A1-F6EECF244321}">
+                <p14:modId xmlns:p14="http://schemas.microsoft.com/office/powerpoint/2010/main" val="1820341826"/>
+              </p:ext>
+            </p:extLst>
+          </p:nvPr>
+        </p:nvGraphicFramePr>
+        <p:xfrm>
+          <a:off x="706438" y="582613"/>
+          <a:ext cx="4013200" cy="6021387"/>
+        </p:xfrm>
+        <a:graphic>
+          <a:graphicData uri="http://schemas.openxmlformats.org/presentationml/2006/ole">
+            <mc:AlternateContent xmlns:mc="http://schemas.openxmlformats.org/markup-compatibility/2006">
+              <mc:Choice xmlns:v="urn:schemas-microsoft-com:vml" Requires="v">
+                <p:oleObj name="Slide" r:id="rId2" imgW="3624030" imgH="5436195" progId="PowerPoint.Slide.12">
+                  <p:embed/>
+                </p:oleObj>
+              </mc:Choice>
+              <mc:Fallback>
+                <p:oleObj name="Slide" r:id="rId2" imgW="3624030" imgH="5436195" progId="PowerPoint.Slide.12">
+                  <p:embed/>
+                  <p:pic>
+                    <p:nvPicPr>
+                      <p:cNvPr id="0" name=""/>
+                      <p:cNvPicPr/>
+                      <p:nvPr/>
+                    </p:nvPicPr>
+                    <p:blipFill>
+                      <a:blip r:embed="rId3"/>
+                      <a:stretch>
+                        <a:fillRect/>
+                      </a:stretch>
+                    </p:blipFill>
+                    <p:spPr>
+                      <a:xfrm>
+                        <a:off x="706438" y="582613"/>
+                        <a:ext cx="4013200" cy="6021387"/>
+                      </a:xfrm>
+                      <a:prstGeom prst="rect">
+                        <a:avLst/>
+                      </a:prstGeom>
+                    </p:spPr>
+                  </p:pic>
+                </p:oleObj>
+              </mc:Fallback>
+            </mc:AlternateContent>
+          </a:graphicData>
+        </a:graphic>
+      </p:graphicFrame>
+      <p:sp>
+        <p:nvSpPr>
+          <p:cNvPr id="4" name="TextBox 3">
+            <a:extLst>
+              <a:ext uri="{FF2B5EF4-FFF2-40B4-BE49-F238E27FC236}">
+                <a16:creationId xmlns:a16="http://schemas.microsoft.com/office/drawing/2014/main" id="{52FA858D-697E-13A9-5C53-0F246A305BA7}"/>
+              </a:ext>
+            </a:extLst>
+          </p:cNvPr>
+          <p:cNvSpPr txBox="1"/>
+          <p:nvPr/>
+        </p:nvSpPr>
+        <p:spPr>
+          <a:xfrm>
+            <a:off x="7109014" y="916311"/>
+            <a:ext cx="4876800" cy="2862322"/>
+          </a:xfrm>
+          <a:prstGeom prst="rect">
+            <a:avLst/>
+          </a:prstGeom>
+          <a:noFill/>
+        </p:spPr>
+        <p:txBody>
+          <a:bodyPr wrap="square" rtlCol="0">
+            <a:spAutoFit/>
+          </a:bodyPr>
+          <a:lstStyle/>
+          <a:p>
+            <a:r>
+              <a:rPr lang="en-GB" sz="1200" dirty="0"/>
+              <a:t>Observations – connectivity-service and connection</a:t>
+            </a:r>
+          </a:p>
+          <a:p>
+            <a:pPr marL="285750" indent="-285750">
+              <a:buFont typeface="Arial" panose="020B0604020202020204" pitchFamily="34" charset="0"/>
+              <a:buChar char="•"/>
+            </a:pPr>
+            <a:r>
+              <a:rPr lang="en-GB" sz="1200" dirty="0"/>
+              <a:t>Routing constraints cost etc are absolute values. These should be ranges etc! </a:t>
+            </a:r>
+          </a:p>
+          <a:p>
+            <a:pPr marL="742950" lvl="1" indent="-285750">
+              <a:buFont typeface="Arial" panose="020B0604020202020204" pitchFamily="34" charset="0"/>
+              <a:buChar char="•"/>
+            </a:pPr>
+            <a:r>
+              <a:rPr lang="en-GB" sz="1200" dirty="0"/>
+              <a:t>There are secondary properties that provide ranges, but these seem to be rather hacky</a:t>
+            </a:r>
+          </a:p>
+          <a:p>
+            <a:pPr marL="742950" lvl="1" indent="-285750">
+              <a:buFont typeface="Arial" panose="020B0604020202020204" pitchFamily="34" charset="0"/>
+              <a:buChar char="•"/>
+            </a:pPr>
+            <a:r>
+              <a:rPr lang="en-GB" sz="1200" dirty="0"/>
+              <a:t>There could be property values that are required to be presented that are independent of the computation constraint and the computation result</a:t>
+            </a:r>
+          </a:p>
+          <a:p>
+            <a:pPr marL="285750" indent="-285750">
+              <a:buFont typeface="Arial" panose="020B0604020202020204" pitchFamily="34" charset="0"/>
+              <a:buChar char="•"/>
+            </a:pPr>
+            <a:r>
+              <a:rPr lang="en-GB" sz="1200" dirty="0"/>
+              <a:t>Link validation mechanism is really a connectivity-service validation mechanism and should be reported on the connection (and the link)</a:t>
+            </a:r>
+          </a:p>
+          <a:p>
+            <a:pPr marL="285750" indent="-285750">
+              <a:buFont typeface="Arial" panose="020B0604020202020204" pitchFamily="34" charset="0"/>
+              <a:buChar char="•"/>
+            </a:pPr>
+            <a:endParaRPr lang="en-GB" sz="1200" dirty="0"/>
+          </a:p>
+          <a:p>
+            <a:r>
+              <a:rPr lang="en-GB" sz="1200" dirty="0"/>
+              <a:t>Use for Link</a:t>
+            </a:r>
+          </a:p>
+          <a:p>
+            <a:pPr marL="171450" indent="-171450">
+              <a:buFont typeface="Arial" panose="020B0604020202020204" pitchFamily="34" charset="0"/>
+              <a:buChar char="•"/>
+            </a:pPr>
+            <a:r>
+              <a:rPr lang="en-GB" sz="1200" dirty="0"/>
+              <a:t>Add link reference (in same way as connection)</a:t>
+            </a:r>
+          </a:p>
+          <a:p>
+            <a:pPr marL="171450" indent="-171450">
+              <a:buFont typeface="Arial" panose="020B0604020202020204" pitchFamily="34" charset="0"/>
+              <a:buChar char="•"/>
+            </a:pPr>
+            <a:endParaRPr lang="en-GB" sz="1200" dirty="0"/>
+          </a:p>
+        </p:txBody>
+      </p:sp>
+      <p:sp>
+        <p:nvSpPr>
+          <p:cNvPr id="8" name="TextBox 7">
+            <a:extLst>
+              <a:ext uri="{FF2B5EF4-FFF2-40B4-BE49-F238E27FC236}">
+                <a16:creationId xmlns:a16="http://schemas.microsoft.com/office/drawing/2014/main" id="{67C71F7A-5A0A-C9E7-7A8B-A2E546C8E251}"/>
+              </a:ext>
+            </a:extLst>
+          </p:cNvPr>
+          <p:cNvSpPr txBox="1"/>
+          <p:nvPr/>
+        </p:nvSpPr>
+        <p:spPr>
+          <a:xfrm>
+            <a:off x="4446496" y="820131"/>
+            <a:ext cx="2070845" cy="2316019"/>
+          </a:xfrm>
+          <a:prstGeom prst="rect">
+            <a:avLst/>
+          </a:prstGeom>
+          <a:noFill/>
+        </p:spPr>
+        <p:txBody>
+          <a:bodyPr wrap="square" rtlCol="0">
+            <a:spAutoFit/>
+          </a:bodyPr>
+          <a:lstStyle/>
+          <a:p>
+            <a:pPr marL="0" indent="0">
+              <a:spcBef>
+                <a:spcPts val="300"/>
+              </a:spcBef>
+              <a:buNone/>
+            </a:pPr>
+            <a:r>
+              <a:rPr lang="en-GB" sz="800" dirty="0">
+                <a:solidFill>
+                  <a:srgbClr val="FF0000"/>
+                </a:solidFill>
+              </a:rPr>
+              <a:t>layer-protocol-name </a:t>
+            </a:r>
+          </a:p>
+          <a:p>
+            <a:pPr marL="0" indent="0">
+              <a:spcBef>
+                <a:spcPts val="300"/>
+              </a:spcBef>
+              <a:buNone/>
+            </a:pPr>
+            <a:r>
+              <a:rPr lang="en-GB" sz="800" dirty="0">
+                <a:solidFill>
+                  <a:srgbClr val="FF0000"/>
+                </a:solidFill>
+              </a:rPr>
+              <a:t>layer-protocol-qualifier</a:t>
+            </a:r>
+          </a:p>
+          <a:p>
+            <a:pPr marL="0" indent="0">
+              <a:spcBef>
+                <a:spcPts val="300"/>
+              </a:spcBef>
+              <a:buNone/>
+            </a:pPr>
+            <a:r>
+              <a:rPr lang="en-GB" sz="800" dirty="0">
+                <a:solidFill>
+                  <a:srgbClr val="FF0000"/>
+                </a:solidFill>
+              </a:rPr>
+              <a:t>leaf direction</a:t>
+            </a:r>
+          </a:p>
+          <a:p>
+            <a:pPr marL="0" indent="0">
+              <a:spcBef>
+                <a:spcPts val="300"/>
+              </a:spcBef>
+              <a:buNone/>
+            </a:pPr>
+            <a:r>
+              <a:rPr lang="en-GB" sz="800" dirty="0">
+                <a:solidFill>
+                  <a:schemeClr val="bg1"/>
+                </a:solidFill>
+                <a:highlight>
+                  <a:srgbClr val="FF0000"/>
+                </a:highlight>
+              </a:rPr>
+              <a:t>end-point</a:t>
+            </a:r>
+          </a:p>
+          <a:p>
+            <a:pPr marL="0" indent="0">
+              <a:spcBef>
+                <a:spcPts val="300"/>
+              </a:spcBef>
+              <a:buNone/>
+            </a:pPr>
+            <a:r>
+              <a:rPr lang="en-GB" sz="800" dirty="0">
+                <a:solidFill>
+                  <a:schemeClr val="bg1"/>
+                </a:solidFill>
+                <a:highlight>
+                  <a:srgbClr val="0000FF"/>
+                </a:highlight>
+              </a:rPr>
+              <a:t>connectivity-constraint</a:t>
+            </a:r>
+          </a:p>
+          <a:p>
+            <a:pPr marL="0" indent="0">
+              <a:spcBef>
+                <a:spcPts val="300"/>
+              </a:spcBef>
+              <a:buNone/>
+            </a:pPr>
+            <a:r>
+              <a:rPr lang="en-GB" sz="800" dirty="0"/>
+              <a:t>	</a:t>
+            </a:r>
+            <a:r>
+              <a:rPr lang="en-GB" sz="800" dirty="0">
+                <a:highlight>
+                  <a:srgbClr val="FFFF00"/>
+                </a:highlight>
+              </a:rPr>
+              <a:t>Includes schedule</a:t>
+            </a:r>
+          </a:p>
+          <a:p>
+            <a:pPr marL="0" indent="0">
+              <a:spcBef>
+                <a:spcPts val="300"/>
+              </a:spcBef>
+              <a:buNone/>
+            </a:pPr>
+            <a:r>
+              <a:rPr lang="en-GB" sz="800" dirty="0">
+                <a:solidFill>
+                  <a:srgbClr val="FF0000"/>
+                </a:solidFill>
+                <a:highlight>
+                  <a:srgbClr val="00FFFF"/>
+                </a:highlight>
+              </a:rPr>
+              <a:t>routing-constraint</a:t>
+            </a:r>
+          </a:p>
+          <a:p>
+            <a:pPr marL="0" indent="0">
+              <a:spcBef>
+                <a:spcPts val="300"/>
+              </a:spcBef>
+              <a:buNone/>
+            </a:pPr>
+            <a:r>
+              <a:rPr lang="en-GB" sz="800" dirty="0">
+                <a:solidFill>
+                  <a:schemeClr val="bg1">
+                    <a:lumMod val="75000"/>
+                  </a:schemeClr>
+                </a:solidFill>
+              </a:rPr>
+              <a:t>topology-constraint</a:t>
+            </a:r>
+          </a:p>
+          <a:p>
+            <a:pPr marL="0" indent="0">
+              <a:spcBef>
+                <a:spcPts val="300"/>
+              </a:spcBef>
+              <a:buNone/>
+            </a:pPr>
+            <a:r>
+              <a:rPr lang="en-GB" sz="800" dirty="0">
+                <a:solidFill>
+                  <a:srgbClr val="FF0000"/>
+                </a:solidFill>
+              </a:rPr>
+              <a:t>resilience-constraint</a:t>
+            </a:r>
+          </a:p>
+          <a:p>
+            <a:pPr marL="0" indent="0">
+              <a:spcBef>
+                <a:spcPts val="300"/>
+              </a:spcBef>
+              <a:buNone/>
+            </a:pPr>
+            <a:r>
+              <a:rPr lang="en-GB" sz="800" dirty="0">
+                <a:solidFill>
+                  <a:schemeClr val="bg1">
+                    <a:lumMod val="75000"/>
+                  </a:schemeClr>
+                </a:solidFill>
+              </a:rPr>
+              <a:t>connection</a:t>
+            </a:r>
+          </a:p>
+          <a:p>
+            <a:pPr marL="0" indent="0">
+              <a:spcBef>
+                <a:spcPts val="300"/>
+              </a:spcBef>
+              <a:buNone/>
+            </a:pPr>
+            <a:r>
+              <a:rPr lang="en-GB" sz="800" dirty="0">
+                <a:solidFill>
+                  <a:schemeClr val="bg1">
+                    <a:lumMod val="75000"/>
+                  </a:schemeClr>
+                </a:solidFill>
+              </a:rPr>
+              <a:t>connectivity-service</a:t>
+            </a:r>
+          </a:p>
+          <a:p>
+            <a:pPr marL="0" indent="0">
+              <a:spcBef>
+                <a:spcPts val="300"/>
+              </a:spcBef>
+              <a:buNone/>
+            </a:pPr>
+            <a:r>
+              <a:rPr lang="en-GB" sz="800" dirty="0">
+                <a:solidFill>
+                  <a:schemeClr val="bg1">
+                    <a:lumMod val="75000"/>
+                  </a:schemeClr>
+                </a:solidFill>
+              </a:rPr>
+              <a:t>internal-point</a:t>
+            </a:r>
+          </a:p>
+          <a:p>
+            <a:pPr marL="0" indent="0">
+              <a:spcBef>
+                <a:spcPts val="300"/>
+              </a:spcBef>
+              <a:buNone/>
+            </a:pPr>
+            <a:r>
+              <a:rPr lang="en-GB" sz="800" dirty="0"/>
+              <a:t>global-class</a:t>
+            </a:r>
+          </a:p>
+          <a:p>
+            <a:pPr marL="0" indent="0">
+              <a:spcBef>
+                <a:spcPts val="300"/>
+              </a:spcBef>
+              <a:buNone/>
+            </a:pPr>
+            <a:r>
+              <a:rPr lang="en-GB" sz="800" dirty="0"/>
+              <a:t>admin-state-</a:t>
+            </a:r>
+            <a:r>
+              <a:rPr lang="en-GB" sz="800" dirty="0" err="1"/>
+              <a:t>pac</a:t>
+            </a:r>
+            <a:endParaRPr lang="en-GB" sz="800" dirty="0"/>
+          </a:p>
+        </p:txBody>
+      </p:sp>
+    </p:spTree>
+    <p:extLst>
+      <p:ext uri="{BB962C8B-B14F-4D97-AF65-F5344CB8AC3E}">
+        <p14:creationId xmlns:p14="http://schemas.microsoft.com/office/powerpoint/2010/main" val="2010985391"/>
+      </p:ext>
+    </p:extLst>
+  </p:cSld>
+  <p:clrMapOvr>
+    <a:masterClrMapping/>
+  </p:clrMapOvr>
+</p:sld>
+</file>
+
+<file path=ppt/slides/slide5.xml><?xml version="1.0" encoding="utf-8"?>
+<p:sld xmlns:a="http://schemas.openxmlformats.org/drawingml/2006/main" xmlns:r="http://schemas.openxmlformats.org/officeDocument/2006/relationships" xmlns:p="http://schemas.openxmlformats.org/presentationml/2006/main">
+  <p:cSld>
+    <p:spTree>
+      <p:nvGrpSpPr>
+        <p:cNvPr id="1" name=""/>
+        <p:cNvGrpSpPr/>
+        <p:nvPr/>
+      </p:nvGrpSpPr>
+      <p:grpSpPr>
+        <a:xfrm>
+          <a:off x="0" y="0"/>
+          <a:ext cx="0" cy="0"/>
+          <a:chOff x="0" y="0"/>
+          <a:chExt cx="0" cy="0"/>
+        </a:xfrm>
+      </p:grpSpPr>
+      <p:sp>
+        <p:nvSpPr>
+          <p:cNvPr id="4" name="Title 3">
+            <a:extLst>
+              <a:ext uri="{FF2B5EF4-FFF2-40B4-BE49-F238E27FC236}">
+                <a16:creationId xmlns:a16="http://schemas.microsoft.com/office/drawing/2014/main" id="{BFF1D15D-48C9-CBF1-C6E8-C5D0154A8E9C}"/>
+              </a:ext>
+            </a:extLst>
+          </p:cNvPr>
+          <p:cNvSpPr>
+            <a:spLocks noGrp="1"/>
+          </p:cNvSpPr>
+          <p:nvPr>
+            <p:ph type="ctrTitle"/>
+          </p:nvPr>
+        </p:nvSpPr>
+        <p:spPr/>
+        <p:txBody>
+          <a:bodyPr/>
+          <a:lstStyle/>
+          <a:p>
+            <a:r>
+              <a:rPr lang="en-GB" dirty="0"/>
+              <a:t>Other connectivity-service and connection adjustments</a:t>
+            </a:r>
+          </a:p>
+        </p:txBody>
+      </p:sp>
+      <p:sp>
+        <p:nvSpPr>
+          <p:cNvPr id="5" name="Subtitle 4">
+            <a:extLst>
+              <a:ext uri="{FF2B5EF4-FFF2-40B4-BE49-F238E27FC236}">
+                <a16:creationId xmlns:a16="http://schemas.microsoft.com/office/drawing/2014/main" id="{9B0649FD-DF6C-6878-275E-D2D328BC59CE}"/>
+              </a:ext>
+            </a:extLst>
+          </p:cNvPr>
+          <p:cNvSpPr>
+            <a:spLocks noGrp="1"/>
+          </p:cNvSpPr>
+          <p:nvPr>
+            <p:ph type="subTitle" idx="1"/>
+          </p:nvPr>
+        </p:nvSpPr>
+        <p:spPr/>
+        <p:txBody>
+          <a:bodyPr/>
+          <a:lstStyle/>
+          <a:p>
+            <a:endParaRPr lang="en-GB"/>
+          </a:p>
+        </p:txBody>
+      </p:sp>
+    </p:spTree>
+    <p:extLst>
+      <p:ext uri="{BB962C8B-B14F-4D97-AF65-F5344CB8AC3E}">
+        <p14:creationId xmlns:p14="http://schemas.microsoft.com/office/powerpoint/2010/main" val="852375642"/>
+      </p:ext>
+    </p:extLst>
+  </p:cSld>
+  <p:clrMapOvr>
+    <a:masterClrMapping/>
+  </p:clrMapOvr>
+</p:sld>
+</file>
+
+<file path=ppt/slides/slide6.xml><?xml version="1.0" encoding="utf-8"?>
+<p:sld xmlns:a="http://schemas.openxmlformats.org/drawingml/2006/main" xmlns:r="http://schemas.openxmlformats.org/officeDocument/2006/relationships" xmlns:p="http://schemas.openxmlformats.org/presentationml/2006/main">
+  <p:cSld>
+    <p:spTree>
+      <p:nvGrpSpPr>
+        <p:cNvPr id="1" name=""/>
+        <p:cNvGrpSpPr/>
+        <p:nvPr/>
+      </p:nvGrpSpPr>
+      <p:grpSpPr>
+        <a:xfrm>
+          <a:off x="0" y="0"/>
+          <a:ext cx="0" cy="0"/>
+          <a:chOff x="0" y="0"/>
+          <a:chExt cx="0" cy="0"/>
+        </a:xfrm>
+      </p:grpSpPr>
+      <p:sp>
+        <p:nvSpPr>
+          <p:cNvPr id="2" name="Title 1">
+            <a:extLst>
+              <a:ext uri="{FF2B5EF4-FFF2-40B4-BE49-F238E27FC236}">
+                <a16:creationId xmlns:a16="http://schemas.microsoft.com/office/drawing/2014/main" id="{DA677B2B-D4AB-43D3-6697-5E0C7425F118}"/>
+              </a:ext>
+            </a:extLst>
+          </p:cNvPr>
+          <p:cNvSpPr>
+            <a:spLocks noGrp="1"/>
+          </p:cNvSpPr>
+          <p:nvPr>
+            <p:ph type="title"/>
+          </p:nvPr>
+        </p:nvSpPr>
+        <p:spPr/>
+        <p:txBody>
+          <a:bodyPr/>
+          <a:lstStyle/>
+          <a:p>
+            <a:r>
+              <a:rPr lang="en-GB" dirty="0"/>
+              <a:t>Other connectivity-service considerations</a:t>
+            </a:r>
+          </a:p>
+        </p:txBody>
+      </p:sp>
+      <p:sp>
+        <p:nvSpPr>
+          <p:cNvPr id="3" name="Content Placeholder 2">
+            <a:extLst>
+              <a:ext uri="{FF2B5EF4-FFF2-40B4-BE49-F238E27FC236}">
+                <a16:creationId xmlns:a16="http://schemas.microsoft.com/office/drawing/2014/main" id="{DC004F9B-DC1B-E354-BAE9-2FB915798EF7}"/>
+              </a:ext>
+            </a:extLst>
+          </p:cNvPr>
+          <p:cNvSpPr>
+            <a:spLocks noGrp="1"/>
+          </p:cNvSpPr>
+          <p:nvPr>
+            <p:ph idx="1"/>
+          </p:nvPr>
+        </p:nvSpPr>
+        <p:spPr/>
+        <p:txBody>
+          <a:bodyPr>
+            <a:normAutofit fontScale="25000" lnSpcReduction="20000"/>
+          </a:bodyPr>
+          <a:lstStyle/>
+          <a:p>
+            <a:r>
+              <a:rPr lang="en-GB" dirty="0"/>
+              <a:t>Multiple services in parallel (service-set) – usually two</a:t>
+            </a:r>
+          </a:p>
+          <a:p>
+            <a:pPr lvl="1"/>
+            <a:r>
+              <a:rPr lang="en-GB" dirty="0"/>
+              <a:t>May simply be parallel creation with no subsequent association</a:t>
+            </a:r>
+          </a:p>
+          <a:p>
+            <a:pPr lvl="1"/>
+            <a:r>
+              <a:rPr lang="en-GB" dirty="0"/>
+              <a:t>May be associated in a set or other more complex structure</a:t>
+            </a:r>
+          </a:p>
+          <a:p>
+            <a:pPr lvl="1"/>
+            <a:r>
+              <a:rPr lang="en-GB" dirty="0"/>
+              <a:t>Where the services form part of an externally applied protection scheme</a:t>
+            </a:r>
+          </a:p>
+          <a:p>
+            <a:r>
+              <a:rPr lang="en-GB" dirty="0"/>
+              <a:t>Service with adjacency creation as a constraint</a:t>
+            </a:r>
+          </a:p>
+          <a:p>
+            <a:pPr lvl="1"/>
+            <a:r>
+              <a:rPr lang="en-GB" dirty="0"/>
+              <a:t>Where the service is to be built across foreign network</a:t>
+            </a:r>
+          </a:p>
+          <a:p>
+            <a:pPr lvl="1"/>
+            <a:r>
+              <a:rPr lang="en-GB" dirty="0"/>
+              <a:t>Where an undiscoverable physical adjacency is to be built as part of the overall work order</a:t>
+            </a:r>
+          </a:p>
+          <a:p>
+            <a:r>
+              <a:rPr lang="en-GB" dirty="0"/>
+              <a:t>Trial service returned details via streaming but not committed to the network</a:t>
+            </a:r>
+          </a:p>
+          <a:p>
+            <a:pPr lvl="1"/>
+            <a:r>
+              <a:rPr lang="en-GB" dirty="0"/>
+              <a:t>Temporary reserve of resources until service either committed to network or deleted</a:t>
+            </a:r>
+          </a:p>
+          <a:p>
+            <a:pPr lvl="1"/>
+            <a:r>
+              <a:rPr lang="en-GB" dirty="0"/>
+              <a:t>No reserve of resources beyond calculation activity (so auto delete of service)</a:t>
+            </a:r>
+          </a:p>
+          <a:p>
+            <a:pPr lvl="2"/>
+            <a:r>
+              <a:rPr lang="en-GB" dirty="0"/>
+              <a:t>Note that during the computation the resources may be acquired and then released after computation</a:t>
+            </a:r>
+          </a:p>
+          <a:p>
+            <a:pPr lvl="1"/>
+            <a:r>
+              <a:rPr lang="en-GB" dirty="0"/>
+              <a:t>Service(s) with alternative routes presented but not provisioned</a:t>
+            </a:r>
+          </a:p>
+          <a:p>
+            <a:pPr lvl="2"/>
+            <a:r>
+              <a:rPr lang="en-GB" dirty="0"/>
+              <a:t>In a multi-level controller environment, where the controller has access to only a portion of the network and there is a complex multi-controller arrangement </a:t>
+            </a:r>
+          </a:p>
+          <a:p>
+            <a:pPr lvl="3"/>
+            <a:r>
+              <a:rPr lang="en-GB" dirty="0"/>
+              <a:t>The higher controller is taking advantage of the lower controller PCE</a:t>
+            </a:r>
+          </a:p>
+          <a:p>
+            <a:pPr lvl="3"/>
+            <a:r>
+              <a:rPr lang="en-GB" dirty="0"/>
+              <a:t>The resources are not reserved</a:t>
+            </a:r>
+          </a:p>
+          <a:p>
+            <a:r>
+              <a:rPr lang="en-GB" dirty="0"/>
+              <a:t>Timed service creation</a:t>
+            </a:r>
+          </a:p>
+          <a:p>
+            <a:pPr lvl="1"/>
+            <a:r>
+              <a:rPr lang="en-GB" dirty="0"/>
+              <a:t>With delayed commit to the network</a:t>
+            </a:r>
+          </a:p>
+          <a:p>
+            <a:pPr lvl="1"/>
+            <a:r>
+              <a:rPr lang="en-GB" dirty="0"/>
+              <a:t>With a fully fledged temporal model</a:t>
+            </a:r>
+          </a:p>
+          <a:p>
+            <a:pPr lvl="1"/>
+            <a:r>
+              <a:rPr lang="en-GB" dirty="0"/>
+              <a:t>Service creation in a temporal topology</a:t>
+            </a:r>
+          </a:p>
+          <a:p>
+            <a:pPr lvl="2"/>
+            <a:r>
+              <a:rPr lang="en-GB" dirty="0"/>
+              <a:t>Where services have start and end time specification</a:t>
+            </a:r>
+          </a:p>
+          <a:p>
+            <a:pPr lvl="2"/>
+            <a:r>
+              <a:rPr lang="en-GB" dirty="0"/>
+              <a:t>Where the network resource model has availability with a temporal dimension</a:t>
+            </a:r>
+          </a:p>
+          <a:p>
+            <a:r>
+              <a:rPr lang="en-GB" dirty="0"/>
+              <a:t>Deep equivalent of the above cases</a:t>
+            </a:r>
+          </a:p>
+          <a:p>
+            <a:r>
+              <a:rPr lang="en-GB" dirty="0"/>
+              <a:t>Path set creation during service creation</a:t>
+            </a:r>
+          </a:p>
+          <a:p>
+            <a:r>
+              <a:rPr lang="en-GB" dirty="0"/>
+              <a:t>Path set creation during trial service activity</a:t>
+            </a:r>
+          </a:p>
+          <a:p>
+            <a:pPr lvl="1"/>
+            <a:r>
+              <a:rPr lang="en-GB" dirty="0"/>
+              <a:t>This may be a proposed path set that is deleted after the trial or is maintained after the trial</a:t>
+            </a:r>
+          </a:p>
+          <a:p>
+            <a:r>
+              <a:rPr lang="en-GB" dirty="0"/>
+              <a:t>Multi-layer service creation (where the NEPs do not exist prior to the creation and are simply implied by the SIPs)</a:t>
+            </a:r>
+          </a:p>
+          <a:p>
+            <a:r>
+              <a:rPr lang="en-GB" dirty="0"/>
+              <a:t>Enhanced connection lifecycle state</a:t>
+            </a:r>
+          </a:p>
+          <a:p>
+            <a:pPr marL="0" indent="0">
+              <a:buNone/>
+            </a:pPr>
+            <a:endParaRPr lang="en-GB" dirty="0"/>
+          </a:p>
+          <a:p>
+            <a:endParaRPr lang="en-GB" dirty="0"/>
+          </a:p>
+        </p:txBody>
+      </p:sp>
+    </p:spTree>
+    <p:extLst>
+      <p:ext uri="{BB962C8B-B14F-4D97-AF65-F5344CB8AC3E}">
+        <p14:creationId xmlns:p14="http://schemas.microsoft.com/office/powerpoint/2010/main" val="2742972397"/>
+      </p:ext>
+    </p:extLst>
+  </p:cSld>
+  <p:clrMapOvr>
+    <a:masterClrMapping/>
+  </p:clrMapOvr>
+</p:sld>
+</file>
+
+<file path=ppt/slides/slide7.xml><?xml version="1.0" encoding="utf-8"?>
+<p:sld xmlns:a="http://schemas.openxmlformats.org/drawingml/2006/main" xmlns:r="http://schemas.openxmlformats.org/officeDocument/2006/relationships" xmlns:p="http://schemas.openxmlformats.org/presentationml/2006/main">
+  <p:cSld>
+    <p:spTree>
+      <p:nvGrpSpPr>
+        <p:cNvPr id="1" name=""/>
+        <p:cNvGrpSpPr/>
+        <p:nvPr/>
+      </p:nvGrpSpPr>
+      <p:grpSpPr>
+        <a:xfrm>
+          <a:off x="0" y="0"/>
+          <a:ext cx="0" cy="0"/>
+          <a:chOff x="0" y="0"/>
+          <a:chExt cx="0" cy="0"/>
+        </a:xfrm>
+      </p:grpSpPr>
+      <p:sp>
+        <p:nvSpPr>
+          <p:cNvPr id="2" name="Title 1">
+            <a:extLst>
+              <a:ext uri="{FF2B5EF4-FFF2-40B4-BE49-F238E27FC236}">
+                <a16:creationId xmlns:a16="http://schemas.microsoft.com/office/drawing/2014/main" id="{9E10414D-561A-F9FB-BF54-91E4CAB2F147}"/>
+              </a:ext>
+            </a:extLst>
+          </p:cNvPr>
+          <p:cNvSpPr>
+            <a:spLocks noGrp="1"/>
+          </p:cNvSpPr>
+          <p:nvPr>
+            <p:ph type="title"/>
+          </p:nvPr>
+        </p:nvSpPr>
+        <p:spPr/>
+        <p:txBody>
+          <a:bodyPr/>
+          <a:lstStyle/>
+          <a:p>
+            <a:r>
+              <a:rPr lang="en-GB" dirty="0"/>
+              <a:t>Multiple connectivity services</a:t>
+            </a:r>
+          </a:p>
+        </p:txBody>
+      </p:sp>
+      <p:sp>
+        <p:nvSpPr>
+          <p:cNvPr id="3" name="Content Placeholder 2">
+            <a:extLst>
+              <a:ext uri="{FF2B5EF4-FFF2-40B4-BE49-F238E27FC236}">
+                <a16:creationId xmlns:a16="http://schemas.microsoft.com/office/drawing/2014/main" id="{8BAF3D60-BB8B-A21B-B51B-F57A8AD66540}"/>
+              </a:ext>
+            </a:extLst>
+          </p:cNvPr>
+          <p:cNvSpPr>
+            <a:spLocks noGrp="1"/>
+          </p:cNvSpPr>
+          <p:nvPr>
+            <p:ph idx="1"/>
+          </p:nvPr>
+        </p:nvSpPr>
+        <p:spPr/>
+        <p:txBody>
+          <a:bodyPr>
+            <a:normAutofit/>
+          </a:bodyPr>
+          <a:lstStyle/>
+          <a:p>
+            <a:r>
+              <a:rPr lang="en-GB" sz="1600" dirty="0"/>
+              <a:t>Connectivity-service allows for subordinate parts</a:t>
+            </a:r>
+            <a:endParaRPr lang="en-GB" sz="1100" dirty="0"/>
+          </a:p>
+          <a:p>
+            <a:pPr marL="457200" lvl="1" indent="0">
+              <a:buNone/>
+            </a:pPr>
+            <a:r>
+              <a:rPr lang="en-GB" sz="1200" dirty="0"/>
+              <a:t> grouping connectivity-services {</a:t>
+            </a:r>
+          </a:p>
+          <a:p>
+            <a:pPr marL="457200" lvl="1" indent="0">
+              <a:buNone/>
+            </a:pPr>
+            <a:r>
+              <a:rPr lang="en-GB" sz="1200" dirty="0"/>
+              <a:t>….</a:t>
+            </a:r>
+          </a:p>
+          <a:p>
+            <a:pPr marL="457200" lvl="1" indent="0">
+              <a:buNone/>
+            </a:pPr>
+            <a:r>
+              <a:rPr lang="en-GB" sz="1200" dirty="0"/>
+              <a:t>        list connectivity-service {</a:t>
+            </a:r>
+          </a:p>
+          <a:p>
+            <a:pPr marL="457200" lvl="1" indent="0">
+              <a:buNone/>
+            </a:pPr>
+            <a:r>
+              <a:rPr lang="en-GB" sz="1200" dirty="0"/>
+              <a:t>            uses connectivity-service;</a:t>
+            </a:r>
+          </a:p>
+          <a:p>
+            <a:pPr marL="457200" lvl="1" indent="0">
+              <a:buNone/>
+            </a:pPr>
+            <a:r>
+              <a:rPr lang="en-GB" sz="1200" dirty="0"/>
+              <a:t>            key 'connectivity-service-</a:t>
+            </a:r>
+            <a:r>
+              <a:rPr lang="en-GB" sz="1200" dirty="0" err="1"/>
+              <a:t>uuid</a:t>
+            </a:r>
+            <a:r>
+              <a:rPr lang="en-GB" sz="1200" dirty="0"/>
+              <a:t>';</a:t>
+            </a:r>
+          </a:p>
+          <a:p>
+            <a:pPr marL="457200" lvl="1" indent="0">
+              <a:buNone/>
+            </a:pPr>
+            <a:r>
+              <a:rPr lang="en-GB" sz="1200" dirty="0"/>
+              <a:t>            description “Collection of </a:t>
+            </a:r>
+            <a:r>
+              <a:rPr lang="en-GB" sz="1200" dirty="0" err="1"/>
+              <a:t>ConnectivityService</a:t>
+            </a:r>
+            <a:r>
+              <a:rPr lang="en-GB" sz="1200" dirty="0"/>
+              <a:t> instances for complex connectivity provisioning.";</a:t>
+            </a:r>
+          </a:p>
+          <a:p>
+            <a:pPr marL="457200" lvl="1" indent="0">
+              <a:buNone/>
+            </a:pPr>
+            <a:r>
+              <a:rPr lang="en-GB" sz="1200" dirty="0"/>
+              <a:t>        }</a:t>
+            </a:r>
+          </a:p>
+          <a:p>
+            <a:r>
+              <a:rPr lang="en-GB" sz="1600" dirty="0"/>
+              <a:t>The structure posted will not be persistent</a:t>
+            </a:r>
+          </a:p>
+          <a:p>
+            <a:pPr lvl="1"/>
+            <a:r>
+              <a:rPr lang="en-GB" sz="1200" dirty="0"/>
+              <a:t>The structure is intended to simply carry multiple services, they do not need to relate as a single thing beyond creation as they will be interrelated by diversity references</a:t>
+            </a:r>
+          </a:p>
+          <a:p>
+            <a:pPr lvl="1"/>
+            <a:r>
+              <a:rPr lang="en-GB" sz="1200" dirty="0"/>
+              <a:t>The grouping is only for co-creation, once created, the services naturally co-exist hence the grouping can be forgotten.</a:t>
+            </a:r>
+          </a:p>
+          <a:p>
+            <a:r>
+              <a:rPr lang="en-GB" sz="1600" dirty="0"/>
+              <a:t>Further work required</a:t>
+            </a:r>
+          </a:p>
+          <a:p>
+            <a:pPr lvl="1"/>
+            <a:endParaRPr lang="en-GB" sz="1200" dirty="0"/>
+          </a:p>
+          <a:p>
+            <a:endParaRPr lang="en-GB" sz="1600" dirty="0"/>
+          </a:p>
+        </p:txBody>
+      </p:sp>
+    </p:spTree>
+    <p:extLst>
+      <p:ext uri="{BB962C8B-B14F-4D97-AF65-F5344CB8AC3E}">
+        <p14:creationId xmlns:p14="http://schemas.microsoft.com/office/powerpoint/2010/main" val="878845385"/>
+      </p:ext>
+    </p:extLst>
+  </p:cSld>
+  <p:clrMapOvr>
+    <a:masterClrMapping/>
+  </p:clrMapOvr>
+</p:sld>
+</file>
+
+<file path=ppt/slides/slide8.xml><?xml version="1.0" encoding="utf-8"?>
+<p:sld xmlns:a="http://schemas.openxmlformats.org/drawingml/2006/main" xmlns:r="http://schemas.openxmlformats.org/officeDocument/2006/relationships" xmlns:p="http://schemas.openxmlformats.org/presentationml/2006/main">
+  <p:cSld>
+    <p:spTree>
+      <p:nvGrpSpPr>
+        <p:cNvPr id="1" name=""/>
+        <p:cNvGrpSpPr/>
+        <p:nvPr/>
+      </p:nvGrpSpPr>
+      <p:grpSpPr>
+        <a:xfrm>
+          <a:off x="0" y="0"/>
+          <a:ext cx="0" cy="0"/>
+          <a:chOff x="0" y="0"/>
+          <a:chExt cx="0" cy="0"/>
+        </a:xfrm>
+      </p:grpSpPr>
+      <p:sp>
+        <p:nvSpPr>
+          <p:cNvPr id="2" name="Title 1">
+            <a:extLst>
+              <a:ext uri="{FF2B5EF4-FFF2-40B4-BE49-F238E27FC236}">
+                <a16:creationId xmlns:a16="http://schemas.microsoft.com/office/drawing/2014/main" id="{F316DB24-E5E6-6FFF-5327-04F975A1D91B}"/>
+              </a:ext>
+            </a:extLst>
+          </p:cNvPr>
+          <p:cNvSpPr>
+            <a:spLocks noGrp="1"/>
+          </p:cNvSpPr>
+          <p:nvPr>
+            <p:ph type="title"/>
+          </p:nvPr>
+        </p:nvSpPr>
+        <p:spPr/>
+        <p:txBody>
+          <a:bodyPr/>
+          <a:lstStyle/>
+          <a:p>
+            <a:r>
+              <a:rPr lang="en-GB" dirty="0"/>
+              <a:t>Complex workflows</a:t>
+            </a:r>
+          </a:p>
+        </p:txBody>
+      </p:sp>
+      <p:sp>
+        <p:nvSpPr>
+          <p:cNvPr id="3" name="Content Placeholder 2">
+            <a:extLst>
+              <a:ext uri="{FF2B5EF4-FFF2-40B4-BE49-F238E27FC236}">
+                <a16:creationId xmlns:a16="http://schemas.microsoft.com/office/drawing/2014/main" id="{376EDC27-57AA-C793-EA4F-2DCF6648D0C6}"/>
+              </a:ext>
+            </a:extLst>
+          </p:cNvPr>
+          <p:cNvSpPr>
+            <a:spLocks noGrp="1"/>
+          </p:cNvSpPr>
+          <p:nvPr>
+            <p:ph idx="1"/>
+          </p:nvPr>
+        </p:nvSpPr>
+        <p:spPr/>
+        <p:txBody>
+          <a:bodyPr>
+            <a:normAutofit fontScale="92500" lnSpcReduction="20000"/>
+          </a:bodyPr>
+          <a:lstStyle/>
+          <a:p>
+            <a:r>
+              <a:rPr lang="en-GB" dirty="0"/>
+              <a:t>Parallel simultaneous need to be built in one coherent operation</a:t>
+            </a:r>
+          </a:p>
+          <a:p>
+            <a:pPr lvl="1"/>
+            <a:r>
+              <a:rPr lang="en-GB" dirty="0"/>
+              <a:t>Choices for multi-layer build workflow are primarily proprietary</a:t>
+            </a:r>
+          </a:p>
+          <a:p>
+            <a:r>
+              <a:rPr lang="en-GB" dirty="0"/>
+              <a:t>For alternative, first alternative needs to be built then removed prior to next alternative</a:t>
+            </a:r>
+          </a:p>
+          <a:p>
+            <a:pPr lvl="1"/>
+            <a:r>
+              <a:rPr lang="en-GB" dirty="0"/>
+              <a:t>Alternatives will be streamed as built and then deleted </a:t>
+            </a:r>
+          </a:p>
+          <a:p>
+            <a:pPr lvl="2"/>
+            <a:r>
+              <a:rPr lang="en-GB" dirty="0"/>
+              <a:t>There needs to be some form of progress indication (this is essentially the progress of the task – perhaps take/enhance </a:t>
+            </a:r>
+            <a:r>
+              <a:rPr lang="en-GB" dirty="0" err="1"/>
+              <a:t>oam</a:t>
+            </a:r>
+            <a:r>
+              <a:rPr lang="en-GB" dirty="0"/>
+              <a:t>-job state and maybe even add an optional </a:t>
+            </a:r>
+            <a:r>
+              <a:rPr lang="en-GB" dirty="0" err="1"/>
+              <a:t>oam</a:t>
+            </a:r>
+            <a:r>
+              <a:rPr lang="en-GB" dirty="0"/>
+              <a:t>-jobs to connectivity-service operation)</a:t>
+            </a:r>
+          </a:p>
+          <a:p>
+            <a:r>
+              <a:rPr lang="en-GB" dirty="0"/>
+              <a:t>The “context” of the build is challenging especially where some services are expected to have been deleted prior to the requirement for the new services</a:t>
+            </a:r>
+          </a:p>
+          <a:p>
+            <a:r>
+              <a:rPr lang="en-GB" dirty="0"/>
+              <a:t>For full support</a:t>
+            </a:r>
+          </a:p>
+          <a:p>
+            <a:pPr lvl="1"/>
+            <a:r>
+              <a:rPr lang="en-GB" dirty="0"/>
+              <a:t>Needs to have temporal+ model</a:t>
+            </a:r>
+          </a:p>
+          <a:p>
+            <a:pPr lvl="1"/>
+            <a:r>
+              <a:rPr lang="en-GB" dirty="0"/>
+              <a:t>May need to provide indication of which infrastructure to use</a:t>
+            </a:r>
+          </a:p>
+        </p:txBody>
+      </p:sp>
+    </p:spTree>
+    <p:extLst>
+      <p:ext uri="{BB962C8B-B14F-4D97-AF65-F5344CB8AC3E}">
+        <p14:creationId xmlns:p14="http://schemas.microsoft.com/office/powerpoint/2010/main" val="1993011323"/>
+      </p:ext>
+    </p:extLst>
+  </p:cSld>
+  <p:clrMapOvr>
+    <a:masterClrMapping/>
+  </p:clrMapOvr>
+</p:sld>
+</file>
+
+<file path=ppt/slides/slide9.xml><?xml version="1.0" encoding="utf-8"?>
+<p:sld xmlns:a="http://schemas.openxmlformats.org/drawingml/2006/main" xmlns:r="http://schemas.openxmlformats.org/officeDocument/2006/relationships" xmlns:p="http://schemas.openxmlformats.org/presentationml/2006/main">
+  <p:cSld>
+    <p:spTree>
+      <p:nvGrpSpPr>
+        <p:cNvPr id="1" name=""/>
+        <p:cNvGrpSpPr/>
+        <p:nvPr/>
+      </p:nvGrpSpPr>
+      <p:grpSpPr>
+        <a:xfrm>
+          <a:off x="0" y="0"/>
+          <a:ext cx="0" cy="0"/>
+          <a:chOff x="0" y="0"/>
+          <a:chExt cx="0" cy="0"/>
+        </a:xfrm>
+      </p:grpSpPr>
+      <p:sp>
+        <p:nvSpPr>
+          <p:cNvPr id="2" name="Title 1">
+            <a:extLst>
+              <a:ext uri="{FF2B5EF4-FFF2-40B4-BE49-F238E27FC236}">
+                <a16:creationId xmlns:a16="http://schemas.microsoft.com/office/drawing/2014/main" id="{98C75426-646B-F699-1844-786BF3CF3869}"/>
+              </a:ext>
+            </a:extLst>
+          </p:cNvPr>
+          <p:cNvSpPr>
+            <a:spLocks noGrp="1"/>
+          </p:cNvSpPr>
+          <p:nvPr>
+            <p:ph type="title"/>
+          </p:nvPr>
+        </p:nvSpPr>
+        <p:spPr/>
+        <p:txBody>
+          <a:bodyPr/>
+          <a:lstStyle/>
+          <a:p>
+            <a:endParaRPr lang="en-GB"/>
+          </a:p>
+        </p:txBody>
+      </p:sp>
+      <p:sp>
+        <p:nvSpPr>
+          <p:cNvPr id="3" name="Content Placeholder 2">
+            <a:extLst>
+              <a:ext uri="{FF2B5EF4-FFF2-40B4-BE49-F238E27FC236}">
+                <a16:creationId xmlns:a16="http://schemas.microsoft.com/office/drawing/2014/main" id="{20835CFB-64CE-79F9-0DF1-29E3B85B7BA3}"/>
+              </a:ext>
+            </a:extLst>
+          </p:cNvPr>
+          <p:cNvSpPr>
+            <a:spLocks noGrp="1"/>
+          </p:cNvSpPr>
+          <p:nvPr>
+            <p:ph idx="1"/>
+          </p:nvPr>
+        </p:nvSpPr>
+        <p:spPr/>
+        <p:txBody>
+          <a:bodyPr/>
+          <a:lstStyle/>
+          <a:p>
+            <a:endParaRPr lang="en-GB"/>
+          </a:p>
+        </p:txBody>
+      </p:sp>
+      <p:graphicFrame>
+        <p:nvGraphicFramePr>
+          <p:cNvPr id="4" name="Object 3">
+            <a:extLst>
+              <a:ext uri="{FF2B5EF4-FFF2-40B4-BE49-F238E27FC236}">
+                <a16:creationId xmlns:a16="http://schemas.microsoft.com/office/drawing/2014/main" id="{F34A2CB1-38D8-5E6D-637B-18487855905A}"/>
+              </a:ext>
+            </a:extLst>
+          </p:cNvPr>
+          <p:cNvGraphicFramePr>
+            <a:graphicFrameLocks noChangeAspect="1"/>
+          </p:cNvGraphicFramePr>
+          <p:nvPr>
+            <p:extLst>
+              <p:ext uri="{D42A27DB-BD31-4B8C-83A1-F6EECF244321}">
+                <p14:modId xmlns:p14="http://schemas.microsoft.com/office/powerpoint/2010/main" val="1258867842"/>
+              </p:ext>
+            </p:extLst>
+          </p:nvPr>
+        </p:nvGraphicFramePr>
+        <p:xfrm>
+          <a:off x="293688" y="411163"/>
+          <a:ext cx="11387137" cy="6405562"/>
+        </p:xfrm>
+        <a:graphic>
+          <a:graphicData uri="http://schemas.openxmlformats.org/presentationml/2006/ole">
+            <mc:AlternateContent xmlns:mc="http://schemas.openxmlformats.org/markup-compatibility/2006">
+              <mc:Choice xmlns:v="urn:schemas-microsoft-com:vml" Requires="v">
+                <p:oleObj name="Slide" r:id="rId2" imgW="6068613" imgH="3415443" progId="PowerPoint.Slide.12">
+                  <p:embed/>
+                </p:oleObj>
+              </mc:Choice>
+              <mc:Fallback>
+                <p:oleObj name="Slide" r:id="rId2" imgW="6068613" imgH="3415443" progId="PowerPoint.Slide.12">
+                  <p:embed/>
+                  <p:pic>
+                    <p:nvPicPr>
+                      <p:cNvPr id="4" name="Object 3">
+                        <a:extLst>
+                          <a:ext uri="{FF2B5EF4-FFF2-40B4-BE49-F238E27FC236}">
+                            <a16:creationId xmlns:a16="http://schemas.microsoft.com/office/drawing/2014/main" id="{F34A2CB1-38D8-5E6D-637B-18487855905A}"/>
+                          </a:ext>
+                        </a:extLst>
+                      </p:cNvPr>
+                      <p:cNvPicPr/>
+                      <p:nvPr/>
+                    </p:nvPicPr>
+                    <p:blipFill>
+                      <a:blip r:embed="rId3"/>
+                      <a:stretch>
+                        <a:fillRect/>
+                      </a:stretch>
+                    </p:blipFill>
+                    <p:spPr>
+                      <a:xfrm>
+                        <a:off x="293688" y="411163"/>
+                        <a:ext cx="11387137" cy="6405562"/>
+                      </a:xfrm>
+                      <a:prstGeom prst="rect">
+                        <a:avLst/>
+                      </a:prstGeom>
+                    </p:spPr>
+                  </p:pic>
+                </p:oleObj>
+              </mc:Fallback>
+            </mc:AlternateContent>
+          </a:graphicData>
+        </a:graphic>
+      </p:graphicFrame>
+      <p:sp>
+        <p:nvSpPr>
+          <p:cNvPr id="5" name="TextBox 4">
+            <a:extLst>
+              <a:ext uri="{FF2B5EF4-FFF2-40B4-BE49-F238E27FC236}">
+                <a16:creationId xmlns:a16="http://schemas.microsoft.com/office/drawing/2014/main" id="{2445E1D0-E659-0A64-542D-1B2AEBE7A4D9}"/>
+              </a:ext>
+            </a:extLst>
+          </p:cNvPr>
+          <p:cNvSpPr txBox="1"/>
+          <p:nvPr/>
+        </p:nvSpPr>
+        <p:spPr>
+          <a:xfrm>
+            <a:off x="0" y="14744"/>
+            <a:ext cx="12002004" cy="430887"/>
+          </a:xfrm>
+          <a:prstGeom prst="rect">
+            <a:avLst/>
+          </a:prstGeom>
+          <a:noFill/>
+        </p:spPr>
+        <p:txBody>
+          <a:bodyPr wrap="none" rtlCol="0">
+            <a:spAutoFit/>
+          </a:bodyPr>
+          <a:lstStyle/>
+          <a:p>
+            <a:r>
+              <a:rPr lang="en-GB" sz="1100" dirty="0">
+                <a:solidFill>
+                  <a:srgbClr val="FF0000"/>
+                </a:solidFill>
+              </a:rPr>
+              <a:t>From otcc2020.ND.010_TAPI-ConnectivityServiceComputationService </a:t>
+            </a:r>
+          </a:p>
+          <a:p>
+            <a:r>
+              <a:rPr lang="en-GB" sz="1100" dirty="0">
+                <a:solidFill>
+                  <a:srgbClr val="FF0000"/>
+                </a:solidFill>
+              </a:rPr>
+              <a:t>at https://github.com/Open-Network-Models-and-Interfaces-ONMI/TAPI-Activities/blob/main/ContributionsForDiscussions/otcc2020.ND.010_TAPI-ConnectivityServiceComputationService.pptx </a:t>
+            </a:r>
+          </a:p>
+        </p:txBody>
+      </p:sp>
+    </p:spTree>
+    <p:extLst>
+      <p:ext uri="{BB962C8B-B14F-4D97-AF65-F5344CB8AC3E}">
+        <p14:creationId xmlns:p14="http://schemas.microsoft.com/office/powerpoint/2010/main" val="1765917076"/>
       </p:ext>
     </p:extLst>
   </p:cSld>

</xml_diff>